<commit_message>
Refine Lecture 3 layouts and reveal restructuring answers
</commit_message>
<xml_diff>
--- a/teaching/macro-applications/downloads/lecture_3.pptx
+++ b/teaching/macro-applications/downloads/lecture_3.pptx
@@ -2,44 +2,44 @@
 <file path=ppt/presentation.xml><?xml version="1.0" encoding="utf-8"?>
 <p:presentation xmlns:p="http://schemas.openxmlformats.org/presentationml/2006/main">
   <p:sldMasterIdLst>
-    <p:sldMasterId xmlns:r="http://schemas.openxmlformats.org/officeDocument/2006/relationships" id="2147483648" r:id="R50c393809d2f4320"/>
+    <p:sldMasterId xmlns:r="http://schemas.openxmlformats.org/officeDocument/2006/relationships" id="2147483648" r:id="Ra5eb8b45cc744182"/>
   </p:sldMasterIdLst>
   <p:notesMasterIdLst>
-    <p:notesMasterId xmlns:r="http://schemas.openxmlformats.org/officeDocument/2006/relationships" r:id="R5b15bebef47e4eb0"/>
+    <p:notesMasterId xmlns:r="http://schemas.openxmlformats.org/officeDocument/2006/relationships" r:id="R0cf7183bec1c4b93"/>
   </p:notesMasterIdLst>
   <p:sldIdLst>
-    <p:sldId xmlns:r="http://schemas.openxmlformats.org/officeDocument/2006/relationships" id="256" r:id="R252c09e5729a441d"/>
-    <p:sldId xmlns:r="http://schemas.openxmlformats.org/officeDocument/2006/relationships" id="257" r:id="Rc985a8e7d2144049"/>
-    <p:sldId xmlns:r="http://schemas.openxmlformats.org/officeDocument/2006/relationships" id="258" r:id="Rf22156d1d08c4516"/>
-    <p:sldId xmlns:r="http://schemas.openxmlformats.org/officeDocument/2006/relationships" id="259" r:id="Re49233a4b5b84850"/>
-    <p:sldId xmlns:r="http://schemas.openxmlformats.org/officeDocument/2006/relationships" id="260" r:id="Rf07d86aefc6840b6"/>
-    <p:sldId xmlns:r="http://schemas.openxmlformats.org/officeDocument/2006/relationships" id="261" r:id="R2dbc37c34463404b"/>
-    <p:sldId xmlns:r="http://schemas.openxmlformats.org/officeDocument/2006/relationships" id="262" r:id="R1eecb2244ab948ac"/>
-    <p:sldId xmlns:r="http://schemas.openxmlformats.org/officeDocument/2006/relationships" id="263" r:id="Rb76cedb5378742af"/>
-    <p:sldId xmlns:r="http://schemas.openxmlformats.org/officeDocument/2006/relationships" id="264" r:id="R3217505334584724"/>
-    <p:sldId xmlns:r="http://schemas.openxmlformats.org/officeDocument/2006/relationships" id="265" r:id="Re97dfc4b37844def"/>
-    <p:sldId xmlns:r="http://schemas.openxmlformats.org/officeDocument/2006/relationships" id="266" r:id="Rb2441d981c614fed"/>
-    <p:sldId xmlns:r="http://schemas.openxmlformats.org/officeDocument/2006/relationships" id="267" r:id="R5dbcd65fdd834a02"/>
-    <p:sldId xmlns:r="http://schemas.openxmlformats.org/officeDocument/2006/relationships" id="268" r:id="R5210a919b857464e"/>
-    <p:sldId xmlns:r="http://schemas.openxmlformats.org/officeDocument/2006/relationships" id="269" r:id="R5314bd8dfa9f4e3b"/>
-    <p:sldId xmlns:r="http://schemas.openxmlformats.org/officeDocument/2006/relationships" id="270" r:id="R1ef619e6079844f7"/>
-    <p:sldId xmlns:r="http://schemas.openxmlformats.org/officeDocument/2006/relationships" id="271" r:id="Re11dce7cebd34d4a"/>
-    <p:sldId xmlns:r="http://schemas.openxmlformats.org/officeDocument/2006/relationships" id="272" r:id="R4a163c9e0e2449e7"/>
-    <p:sldId xmlns:r="http://schemas.openxmlformats.org/officeDocument/2006/relationships" id="273" r:id="Rc413555e1ddb4c8c"/>
-    <p:sldId xmlns:r="http://schemas.openxmlformats.org/officeDocument/2006/relationships" id="274" r:id="Re5a3ba9066754ab7"/>
-    <p:sldId xmlns:r="http://schemas.openxmlformats.org/officeDocument/2006/relationships" id="275" r:id="R6c6aee24b238410a"/>
-    <p:sldId xmlns:r="http://schemas.openxmlformats.org/officeDocument/2006/relationships" id="276" r:id="R9312c297670e4d03"/>
-    <p:sldId xmlns:r="http://schemas.openxmlformats.org/officeDocument/2006/relationships" id="277" r:id="Ra272090f07724bb1"/>
-    <p:sldId xmlns:r="http://schemas.openxmlformats.org/officeDocument/2006/relationships" id="278" r:id="R08df9296c9584852"/>
-    <p:sldId xmlns:r="http://schemas.openxmlformats.org/officeDocument/2006/relationships" id="279" r:id="Ra46cb714fd944bf1"/>
-    <p:sldId xmlns:r="http://schemas.openxmlformats.org/officeDocument/2006/relationships" id="280" r:id="R2a1c653fda07419e"/>
-    <p:sldId xmlns:r="http://schemas.openxmlformats.org/officeDocument/2006/relationships" id="281" r:id="R8e081b0b21dc4266"/>
-    <p:sldId xmlns:r="http://schemas.openxmlformats.org/officeDocument/2006/relationships" id="282" r:id="Re83a14fcd2b243ab"/>
-    <p:sldId xmlns:r="http://schemas.openxmlformats.org/officeDocument/2006/relationships" id="283" r:id="Rf890eef86b0949c0"/>
-    <p:sldId xmlns:r="http://schemas.openxmlformats.org/officeDocument/2006/relationships" id="284" r:id="Rd532589008c34c4b"/>
-    <p:sldId xmlns:r="http://schemas.openxmlformats.org/officeDocument/2006/relationships" id="285" r:id="R6a49e00e3ad74a17"/>
-    <p:sldId xmlns:r="http://schemas.openxmlformats.org/officeDocument/2006/relationships" id="286" r:id="R872d0432b6ce41a4"/>
-    <p:sldId xmlns:r="http://schemas.openxmlformats.org/officeDocument/2006/relationships" id="287" r:id="R4360b04ad37f4b87"/>
+    <p:sldId xmlns:r="http://schemas.openxmlformats.org/officeDocument/2006/relationships" id="256" r:id="R40d4c66bb1e640c3"/>
+    <p:sldId xmlns:r="http://schemas.openxmlformats.org/officeDocument/2006/relationships" id="257" r:id="Re7f23336ab5a4d66"/>
+    <p:sldId xmlns:r="http://schemas.openxmlformats.org/officeDocument/2006/relationships" id="258" r:id="R6493c6f2ea924a4d"/>
+    <p:sldId xmlns:r="http://schemas.openxmlformats.org/officeDocument/2006/relationships" id="259" r:id="R6586104c68ad4a8a"/>
+    <p:sldId xmlns:r="http://schemas.openxmlformats.org/officeDocument/2006/relationships" id="260" r:id="R9d5c71df2c51409b"/>
+    <p:sldId xmlns:r="http://schemas.openxmlformats.org/officeDocument/2006/relationships" id="261" r:id="Rf4bff76161644312"/>
+    <p:sldId xmlns:r="http://schemas.openxmlformats.org/officeDocument/2006/relationships" id="262" r:id="Rdc10e91284a24402"/>
+    <p:sldId xmlns:r="http://schemas.openxmlformats.org/officeDocument/2006/relationships" id="263" r:id="R754cac3453054678"/>
+    <p:sldId xmlns:r="http://schemas.openxmlformats.org/officeDocument/2006/relationships" id="264" r:id="Rf81819d9045d4be1"/>
+    <p:sldId xmlns:r="http://schemas.openxmlformats.org/officeDocument/2006/relationships" id="265" r:id="R125875f7add94fff"/>
+    <p:sldId xmlns:r="http://schemas.openxmlformats.org/officeDocument/2006/relationships" id="266" r:id="R56de9e13eb734276"/>
+    <p:sldId xmlns:r="http://schemas.openxmlformats.org/officeDocument/2006/relationships" id="267" r:id="R70d6ff0bb0494258"/>
+    <p:sldId xmlns:r="http://schemas.openxmlformats.org/officeDocument/2006/relationships" id="268" r:id="R63ea99741cd24ea5"/>
+    <p:sldId xmlns:r="http://schemas.openxmlformats.org/officeDocument/2006/relationships" id="269" r:id="R0e37bf8f09bb4499"/>
+    <p:sldId xmlns:r="http://schemas.openxmlformats.org/officeDocument/2006/relationships" id="270" r:id="Rdf72c581371a45b7"/>
+    <p:sldId xmlns:r="http://schemas.openxmlformats.org/officeDocument/2006/relationships" id="271" r:id="R2439f8e531c34723"/>
+    <p:sldId xmlns:r="http://schemas.openxmlformats.org/officeDocument/2006/relationships" id="272" r:id="R146864f9a4c84537"/>
+    <p:sldId xmlns:r="http://schemas.openxmlformats.org/officeDocument/2006/relationships" id="273" r:id="Rdafac062b75042dc"/>
+    <p:sldId xmlns:r="http://schemas.openxmlformats.org/officeDocument/2006/relationships" id="274" r:id="Rfe8a51e152d6462a"/>
+    <p:sldId xmlns:r="http://schemas.openxmlformats.org/officeDocument/2006/relationships" id="275" r:id="R0e801dfb1d664237"/>
+    <p:sldId xmlns:r="http://schemas.openxmlformats.org/officeDocument/2006/relationships" id="276" r:id="R76cda800cd794baa"/>
+    <p:sldId xmlns:r="http://schemas.openxmlformats.org/officeDocument/2006/relationships" id="277" r:id="R71591d7fdc934c12"/>
+    <p:sldId xmlns:r="http://schemas.openxmlformats.org/officeDocument/2006/relationships" id="278" r:id="R4c4df11681624079"/>
+    <p:sldId xmlns:r="http://schemas.openxmlformats.org/officeDocument/2006/relationships" id="279" r:id="Rc6d5402c61204e26"/>
+    <p:sldId xmlns:r="http://schemas.openxmlformats.org/officeDocument/2006/relationships" id="280" r:id="R599c3a8eb90e4b09"/>
+    <p:sldId xmlns:r="http://schemas.openxmlformats.org/officeDocument/2006/relationships" id="281" r:id="R059b60cca18f4f12"/>
+    <p:sldId xmlns:r="http://schemas.openxmlformats.org/officeDocument/2006/relationships" id="282" r:id="R771627d6fb1f4d4b"/>
+    <p:sldId xmlns:r="http://schemas.openxmlformats.org/officeDocument/2006/relationships" id="283" r:id="Re201ef10c9a941f2"/>
+    <p:sldId xmlns:r="http://schemas.openxmlformats.org/officeDocument/2006/relationships" id="284" r:id="R29b652824d234e26"/>
+    <p:sldId xmlns:r="http://schemas.openxmlformats.org/officeDocument/2006/relationships" id="285" r:id="R1b1c1a6e12aa4936"/>
+    <p:sldId xmlns:r="http://schemas.openxmlformats.org/officeDocument/2006/relationships" id="286" r:id="R0f56ef67fc9b487f"/>
+    <p:sldId xmlns:r="http://schemas.openxmlformats.org/officeDocument/2006/relationships" id="287" r:id="Rf0860e0095594101"/>
   </p:sldIdLst>
   <p:sldSz cx="12192000" cy="6858000"/>
   <p:notesSz cx="6858000" cy="9144000"/>
@@ -718,7 +718,7 @@
           </a:p>
           <a:p xmlns:a="http://schemas.openxmlformats.org/drawingml/2006/main">
             <a:r>
-              <a:t>Consequences of international trade Is there a pro-competitive effect? If so, does it increase welfare in all countries?</a:t>
+              <a:t>Consequences of international trade Does more competition always raise welfare? Lower prices help consumers. What happens to producers and transport costs?</a:t>
             </a:r>
           </a:p>
           <a:p xmlns:a="http://schemas.openxmlformats.org/drawingml/2006/main">
@@ -1178,7 +1178,7 @@
           </a:p>
           <a:p xmlns:a="http://schemas.openxmlformats.org/drawingml/2006/main">
             <a:r>
-              <a:t>Market size and industrial restructuring Questions What is the effect of an increased market size on the industry itself? Can some firms leave the market because of the increased competition? If so, is this beneficial for the countries involved?</a:t>
+              <a:t>Market size and industrial restructuring How does a larger market change the industry? More firms compete at first. After exit, the surviving firms are larger. Why might firms exit? The initial price falls below average cost, so firms make losses. Can welfare rise even when firms exit? Yes. In this free-entry model, profits return to zero while consumers pay less.</a:t>
             </a:r>
           </a:p>
           <a:p xmlns:a="http://schemas.openxmlformats.org/drawingml/2006/main">
@@ -1293,7 +1293,7 @@
           </a:p>
           <a:p xmlns:a="http://schemas.openxmlformats.org/drawingml/2006/main">
             <a:r>
-              <a:t>Market size and industrial restructuring Brander and Krugman’s model (1983) with free entry provides an answer. The free entry condition allows us to pin down the number of firms in the market and therefore to understand the effect of trade on the number of firms. First, we look at the closed economy model.</a:t>
+              <a:t>Allowing entry and exit The number of firms can now change. Earlier: a fixed number One firm in each country. Now: free entry Entry and exit determine how many firms remain. Start with a closed economy, then open the markets. Brander and Krugman (1983).</a:t>
             </a:r>
           </a:p>
           <a:p xmlns:a="http://schemas.openxmlformats.org/drawingml/2006/main">
@@ -1753,7 +1753,7 @@
           </a:p>
           <a:p xmlns:a="http://schemas.openxmlformats.org/drawingml/2006/main">
             <a:r>
-              <a:t>Context One of the main benefits of the Single Market is that firms have access to a bigger market . A larger market means more competition between firms, lower prices and increased consumer welfare.</a:t>
+              <a:t>What does a bigger market change? The Single Market lets firms reach customers across borders. More competition Firms face more rivals. Mark-ups and prices fall. Larger firms Surviving firms sell more. Fixed costs are spread over more output. Who gains from integration — and who loses?</a:t>
             </a:r>
           </a:p>
           <a:p xmlns:a="http://schemas.openxmlformats.org/drawingml/2006/main">
@@ -2558,7 +2558,7 @@
           </a:p>
           <a:p xmlns:a="http://schemas.openxmlformats.org/drawingml/2006/main">
             <a:r>
-              <a:t>Next lecture We will talk about migration.</a:t>
+              <a:t>Next lecture Migration What changes when workers, as well as goods, can cross borders? Wages and employment · Who gains and loses · Trade and labour mobility</a:t>
             </a:r>
           </a:p>
           <a:p xmlns:a="http://schemas.openxmlformats.org/drawingml/2006/main">
@@ -3823,7 +3823,7 @@
           </a:p>
           <a:p xmlns:a="http://schemas.openxmlformats.org/drawingml/2006/main">
             <a:r>
-              <a:t>Oligopoly: the Home firm’s problem Choose sales in each market to maximise profit: max x , x * p x + p * x * − c x − c g x * − F \max_{x,x^*}\;px+p^*x^*-cx-\frac{c}{g}x^*-F Home demand p = a − b ( x + y ) p=a-b(x+y) Foreign demand p * = a − b ( x * + y * ) p^*=a-b(x^*+y^*) Substitute the demand functions into the profit function and calculate the two first-order conditions .</a:t>
+              <a:t>Oligopoly: the Home firm’s problem Choose sales at home and abroad to maximise profit: max x , x * ( p − c ) x + ( p * − c g ) x * − F \max_{x,x^*}\;(p-c)x+\left(p^*-\frac{c}{g}\right)x^*-F Market Demand Marginal cost Home p = a − b ( x + y ) p=a-b(x+y) c c Foreign p * = a − b ( x * + y * ) p^*=a-b(x^*+y^*) c / g c/g Substitute these demand functions and find the two first-order conditions .</a:t>
             </a:r>
           </a:p>
           <a:p xmlns:a="http://schemas.openxmlformats.org/drawingml/2006/main">
@@ -4130,7 +4130,7 @@
           <p:cNvPr id="3" name="Title">
             <a:extLst xmlns:a="http://schemas.openxmlformats.org/drawingml/2006/main">
               <a:ext uri="{FF2B5EF4-FFF2-40B4-BE49-F238E27FC236}">
-                <a16:creationId xmlns:a16="http://schemas.microsoft.com/office/drawing/2014/main" id="{A8087353-6E70-43C4-9679-882CD8D35D8B}"/>
+                <a16:creationId xmlns:a16="http://schemas.microsoft.com/office/drawing/2014/main" id="{D6493360-2D5D-4750-AADB-AAF63D1BD169}"/>
               </a:ext>
             </a:extLst>
           </p:cNvPr>
@@ -4359,7 +4359,7 @@
           <p:cNvPr id="2" name="Subtitle">
             <a:extLst xmlns:a="http://schemas.openxmlformats.org/drawingml/2006/main">
               <a:ext uri="{FF2B5EF4-FFF2-40B4-BE49-F238E27FC236}">
-                <a16:creationId xmlns:a16="http://schemas.microsoft.com/office/drawing/2014/main" id="{BBD43156-C61A-43C4-8212-2E6FBAABE838}"/>
+                <a16:creationId xmlns:a16="http://schemas.microsoft.com/office/drawing/2014/main" id="{A1377BBE-2CA8-4863-B962-EB5FDF6A21FD}"/>
               </a:ext>
             </a:extLst>
           </p:cNvPr>
@@ -4605,7 +4605,7 @@
           <p:cNvPr id="2" name="Section title">
             <a:extLst xmlns:a="http://schemas.openxmlformats.org/drawingml/2006/main">
               <a:ext uri="{FF2B5EF4-FFF2-40B4-BE49-F238E27FC236}">
-                <a16:creationId xmlns:a16="http://schemas.microsoft.com/office/drawing/2014/main" id="{F9DA45F2-8814-4FE9-9D8F-857C80632030}"/>
+                <a16:creationId xmlns:a16="http://schemas.microsoft.com/office/drawing/2014/main" id="{1982C5CA-6E2C-4707-8367-36C45F48FFC5}"/>
               </a:ext>
             </a:extLst>
           </p:cNvPr>
@@ -4851,7 +4851,7 @@
           <p:cNvPr id="3" name="Title">
             <a:extLst xmlns:a="http://schemas.openxmlformats.org/drawingml/2006/main">
               <a:ext uri="{FF2B5EF4-FFF2-40B4-BE49-F238E27FC236}">
-                <a16:creationId xmlns:a16="http://schemas.microsoft.com/office/drawing/2014/main" id="{C98A9A78-1DFE-4984-B408-E24CF3087244}"/>
+                <a16:creationId xmlns:a16="http://schemas.microsoft.com/office/drawing/2014/main" id="{9D7ADCD7-203D-4B89-AA54-AAF5706CA5CD}"/>
               </a:ext>
             </a:extLst>
           </p:cNvPr>
@@ -5080,7 +5080,7 @@
           <p:cNvPr id="2" name="Body">
             <a:extLst xmlns:a="http://schemas.openxmlformats.org/drawingml/2006/main">
               <a:ext uri="{FF2B5EF4-FFF2-40B4-BE49-F238E27FC236}">
-                <a16:creationId xmlns:a16="http://schemas.microsoft.com/office/drawing/2014/main" id="{125CE909-8BA1-445E-8896-71B269325F7E}"/>
+                <a16:creationId xmlns:a16="http://schemas.microsoft.com/office/drawing/2014/main" id="{DE04BED0-DD49-4A84-9935-DD44DB4BDD59}"/>
               </a:ext>
             </a:extLst>
           </p:cNvPr>
@@ -5326,7 +5326,7 @@
           <p:cNvPr id="4" name="Title">
             <a:extLst xmlns:a="http://schemas.openxmlformats.org/drawingml/2006/main">
               <a:ext uri="{FF2B5EF4-FFF2-40B4-BE49-F238E27FC236}">
-                <a16:creationId xmlns:a16="http://schemas.microsoft.com/office/drawing/2014/main" id="{835BE333-E54D-4E8B-9AA5-1F6EC886D669}"/>
+                <a16:creationId xmlns:a16="http://schemas.microsoft.com/office/drawing/2014/main" id="{0A9F45B0-B0F8-47E4-85F1-40A9D66C066F}"/>
               </a:ext>
             </a:extLst>
           </p:cNvPr>
@@ -5555,7 +5555,7 @@
           <p:cNvPr id="2" name="Left column">
             <a:extLst xmlns:a="http://schemas.openxmlformats.org/drawingml/2006/main">
               <a:ext uri="{FF2B5EF4-FFF2-40B4-BE49-F238E27FC236}">
-                <a16:creationId xmlns:a16="http://schemas.microsoft.com/office/drawing/2014/main" id="{629FD119-807B-4A31-B8B4-7C8BB9367D1D}"/>
+                <a16:creationId xmlns:a16="http://schemas.microsoft.com/office/drawing/2014/main" id="{C4C9811F-6721-48A0-934C-25C2FC77EDF4}"/>
               </a:ext>
             </a:extLst>
           </p:cNvPr>
@@ -5784,7 +5784,7 @@
           <p:cNvPr id="3" name="Right column">
             <a:extLst xmlns:a="http://schemas.openxmlformats.org/drawingml/2006/main">
               <a:ext uri="{FF2B5EF4-FFF2-40B4-BE49-F238E27FC236}">
-                <a16:creationId xmlns:a16="http://schemas.microsoft.com/office/drawing/2014/main" id="{6C57513F-60A0-417E-8A45-128A25C8C57A}"/>
+                <a16:creationId xmlns:a16="http://schemas.microsoft.com/office/drawing/2014/main" id="{7D9CC9D6-FA61-439B-B4DB-C89773A5D700}"/>
               </a:ext>
             </a:extLst>
           </p:cNvPr>
@@ -6030,7 +6030,7 @@
           <p:cNvPr id="3" name="Title">
             <a:extLst xmlns:a="http://schemas.openxmlformats.org/drawingml/2006/main">
               <a:ext uri="{FF2B5EF4-FFF2-40B4-BE49-F238E27FC236}">
-                <a16:creationId xmlns:a16="http://schemas.microsoft.com/office/drawing/2014/main" id="{0240BFEF-852C-401E-97E5-3174E238DF2D}"/>
+                <a16:creationId xmlns:a16="http://schemas.microsoft.com/office/drawing/2014/main" id="{3FF72CE8-8762-4469-9535-584F5B8F52C0}"/>
               </a:ext>
             </a:extLst>
           </p:cNvPr>
@@ -6259,7 +6259,7 @@
           <p:cNvPr id="2" name="Left column">
             <a:extLst xmlns:a="http://schemas.openxmlformats.org/drawingml/2006/main">
               <a:ext uri="{FF2B5EF4-FFF2-40B4-BE49-F238E27FC236}">
-                <a16:creationId xmlns:a16="http://schemas.microsoft.com/office/drawing/2014/main" id="{57277D9C-3D75-4EBF-A283-137A61B35720}"/>
+                <a16:creationId xmlns:a16="http://schemas.microsoft.com/office/drawing/2014/main" id="{9BD9BF2D-328E-4E8A-83D6-56DC70FD6DAD}"/>
               </a:ext>
             </a:extLst>
           </p:cNvPr>
@@ -6526,12 +6526,12 @@
   </p:cSld>
   <p:clrMap bg1="lt1" tx1="dk1" bg2="lt2" tx2="dk2" accent1="accent1" accent2="accent2" accent3="accent3" accent4="accent4" accent5="accent5" accent6="accent6" hlink="hlink" folHlink="folHlink"/>
   <p:sldLayoutIdLst>
-    <p:sldLayoutId xmlns:r="http://schemas.openxmlformats.org/officeDocument/2006/relationships" id="2147483649" r:id="Rb731846be5d84fed"/>
-    <p:sldLayoutId xmlns:r="http://schemas.openxmlformats.org/officeDocument/2006/relationships" id="2147483650" r:id="R89fd37438aba46ca"/>
-    <p:sldLayoutId xmlns:r="http://schemas.openxmlformats.org/officeDocument/2006/relationships" id="2147483651" r:id="Rd5ad8edf40d14e99"/>
-    <p:sldLayoutId xmlns:r="http://schemas.openxmlformats.org/officeDocument/2006/relationships" id="2147483652" r:id="R56737b3ea403486a"/>
-    <p:sldLayoutId xmlns:r="http://schemas.openxmlformats.org/officeDocument/2006/relationships" id="2147483653" r:id="R28af1f16fd214794"/>
-    <p:sldLayoutId xmlns:r="http://schemas.openxmlformats.org/officeDocument/2006/relationships" id="2147483654" r:id="Rb3eb172a4bc34baa"/>
+    <p:sldLayoutId xmlns:r="http://schemas.openxmlformats.org/officeDocument/2006/relationships" id="2147483649" r:id="R9be0c7fb28fd4e4b"/>
+    <p:sldLayoutId xmlns:r="http://schemas.openxmlformats.org/officeDocument/2006/relationships" id="2147483650" r:id="R3760e0dcf3a14ff1"/>
+    <p:sldLayoutId xmlns:r="http://schemas.openxmlformats.org/officeDocument/2006/relationships" id="2147483651" r:id="R98d631802cf24050"/>
+    <p:sldLayoutId xmlns:r="http://schemas.openxmlformats.org/officeDocument/2006/relationships" id="2147483652" r:id="Rff18c465b6e94a78"/>
+    <p:sldLayoutId xmlns:r="http://schemas.openxmlformats.org/officeDocument/2006/relationships" id="2147483653" r:id="R0aae4352d6ed400e"/>
+    <p:sldLayoutId xmlns:r="http://schemas.openxmlformats.org/officeDocument/2006/relationships" id="2147483654" r:id="R1798f378e4f24b54"/>
   </p:sldLayoutIdLst>
   <p:txStyles>
     <p:titleStyle>
@@ -7075,7 +7075,7 @@
           <p:cNvPr id="2" name="">
             <a:extLst xmlns:a="http://schemas.openxmlformats.org/drawingml/2006/main">
               <a:ext uri="{FF2B5EF4-FFF2-40B4-BE49-F238E27FC236}">
-                <a16:creationId xmlns:a16="http://schemas.microsoft.com/office/drawing/2014/main" id="{D95C3FF6-E303-4626-817A-EF9445ABAE85}"/>
+                <a16:creationId xmlns:a16="http://schemas.microsoft.com/office/drawing/2014/main" id="{E56599A0-1FDF-40FD-8345-FC9B976E334B}"/>
               </a:ext>
             </a:extLst>
           </p:cNvPr>
@@ -7085,7 +7085,7 @@
           <p:nvPr/>
         </p:nvPicPr>
         <p:blipFill>
-          <a:blip xmlns:r="http://schemas.openxmlformats.org/officeDocument/2006/relationships" xmlns:a="http://schemas.openxmlformats.org/drawingml/2006/main" r:embed="R0ca5741eaf014a43"/>
+          <a:blip xmlns:r="http://schemas.openxmlformats.org/officeDocument/2006/relationships" xmlns:a="http://schemas.openxmlformats.org/drawingml/2006/main" r:embed="R54f0812d6de7468a"/>
           <a:stretch xmlns:a="http://schemas.openxmlformats.org/drawingml/2006/main"/>
         </p:blipFill>
         <p:spPr>
@@ -7101,7 +7101,7 @@
     </p:spTree>
     <p:extLst>
       <p:ext uri="{BB962C8B-B14F-4D97-AF65-F5344CB8AC3E}">
-        <p14:creationId xmlns:p14="http://schemas.microsoft.com/office/powerpoint/2010/main" val="161742045"/>
+        <p14:creationId xmlns:p14="http://schemas.microsoft.com/office/powerpoint/2010/main" val="436615682"/>
       </p:ext>
     </p:extLst>
   </p:cSld>
@@ -7125,7 +7125,7 @@
           <p:cNvPr id="2" name="">
             <a:extLst xmlns:a="http://schemas.openxmlformats.org/drawingml/2006/main">
               <a:ext uri="{FF2B5EF4-FFF2-40B4-BE49-F238E27FC236}">
-                <a16:creationId xmlns:a16="http://schemas.microsoft.com/office/drawing/2014/main" id="{C46487DA-E983-4D47-BDB7-3C472E1BD201}"/>
+                <a16:creationId xmlns:a16="http://schemas.microsoft.com/office/drawing/2014/main" id="{79153719-CFAC-4E3F-8F27-21B1C375C22A}"/>
               </a:ext>
             </a:extLst>
           </p:cNvPr>
@@ -7135,7 +7135,7 @@
           <p:nvPr/>
         </p:nvPicPr>
         <p:blipFill>
-          <a:blip xmlns:r="http://schemas.openxmlformats.org/officeDocument/2006/relationships" xmlns:a="http://schemas.openxmlformats.org/drawingml/2006/main" r:embed="R25fae956fb0a4493"/>
+          <a:blip xmlns:r="http://schemas.openxmlformats.org/officeDocument/2006/relationships" xmlns:a="http://schemas.openxmlformats.org/drawingml/2006/main" r:embed="R42f5c17b53894515"/>
           <a:stretch xmlns:a="http://schemas.openxmlformats.org/drawingml/2006/main"/>
         </p:blipFill>
         <p:spPr>
@@ -7151,7 +7151,7 @@
     </p:spTree>
     <p:extLst>
       <p:ext uri="{BB962C8B-B14F-4D97-AF65-F5344CB8AC3E}">
-        <p14:creationId xmlns:p14="http://schemas.microsoft.com/office/powerpoint/2010/main" val="563916584"/>
+        <p14:creationId xmlns:p14="http://schemas.microsoft.com/office/powerpoint/2010/main" val="1186395042"/>
       </p:ext>
     </p:extLst>
   </p:cSld>
@@ -7175,7 +7175,7 @@
           <p:cNvPr id="2" name="">
             <a:extLst xmlns:a="http://schemas.openxmlformats.org/drawingml/2006/main">
               <a:ext uri="{FF2B5EF4-FFF2-40B4-BE49-F238E27FC236}">
-                <a16:creationId xmlns:a16="http://schemas.microsoft.com/office/drawing/2014/main" id="{B6DAE3BF-271F-4581-BB2E-ED615D4D093B}"/>
+                <a16:creationId xmlns:a16="http://schemas.microsoft.com/office/drawing/2014/main" id="{2C3B90ED-33C8-4C31-A688-E9C9DE82451D}"/>
               </a:ext>
             </a:extLst>
           </p:cNvPr>
@@ -7185,7 +7185,7 @@
           <p:nvPr/>
         </p:nvPicPr>
         <p:blipFill>
-          <a:blip xmlns:r="http://schemas.openxmlformats.org/officeDocument/2006/relationships" xmlns:a="http://schemas.openxmlformats.org/drawingml/2006/main" r:embed="R0f349ca14db34717"/>
+          <a:blip xmlns:r="http://schemas.openxmlformats.org/officeDocument/2006/relationships" xmlns:a="http://schemas.openxmlformats.org/drawingml/2006/main" r:embed="R695b3549edb14e4c"/>
           <a:stretch xmlns:a="http://schemas.openxmlformats.org/drawingml/2006/main"/>
         </p:blipFill>
         <p:spPr>
@@ -7201,7 +7201,7 @@
     </p:spTree>
     <p:extLst>
       <p:ext uri="{BB962C8B-B14F-4D97-AF65-F5344CB8AC3E}">
-        <p14:creationId xmlns:p14="http://schemas.microsoft.com/office/powerpoint/2010/main" val="241663102"/>
+        <p14:creationId xmlns:p14="http://schemas.microsoft.com/office/powerpoint/2010/main" val="882294915"/>
       </p:ext>
     </p:extLst>
   </p:cSld>
@@ -7225,7 +7225,7 @@
           <p:cNvPr id="2" name="">
             <a:extLst xmlns:a="http://schemas.openxmlformats.org/drawingml/2006/main">
               <a:ext uri="{FF2B5EF4-FFF2-40B4-BE49-F238E27FC236}">
-                <a16:creationId xmlns:a16="http://schemas.microsoft.com/office/drawing/2014/main" id="{F3476B65-2824-4CB9-B47E-670204B1D3FA}"/>
+                <a16:creationId xmlns:a16="http://schemas.microsoft.com/office/drawing/2014/main" id="{09B4E229-629C-4556-957F-3AEDB9B7C875}"/>
               </a:ext>
             </a:extLst>
           </p:cNvPr>
@@ -7235,7 +7235,7 @@
           <p:nvPr/>
         </p:nvPicPr>
         <p:blipFill>
-          <a:blip xmlns:r="http://schemas.openxmlformats.org/officeDocument/2006/relationships" xmlns:a="http://schemas.openxmlformats.org/drawingml/2006/main" r:embed="R4735594d8bf04e0c"/>
+          <a:blip xmlns:r="http://schemas.openxmlformats.org/officeDocument/2006/relationships" xmlns:a="http://schemas.openxmlformats.org/drawingml/2006/main" r:embed="R4ba00444db524a6c"/>
           <a:stretch xmlns:a="http://schemas.openxmlformats.org/drawingml/2006/main"/>
         </p:blipFill>
         <p:spPr>
@@ -7251,7 +7251,7 @@
     </p:spTree>
     <p:extLst>
       <p:ext uri="{BB962C8B-B14F-4D97-AF65-F5344CB8AC3E}">
-        <p14:creationId xmlns:p14="http://schemas.microsoft.com/office/powerpoint/2010/main" val="1318028482"/>
+        <p14:creationId xmlns:p14="http://schemas.microsoft.com/office/powerpoint/2010/main" val="242584312"/>
       </p:ext>
     </p:extLst>
   </p:cSld>
@@ -7275,7 +7275,7 @@
           <p:cNvPr id="2" name="">
             <a:extLst xmlns:a="http://schemas.openxmlformats.org/drawingml/2006/main">
               <a:ext uri="{FF2B5EF4-FFF2-40B4-BE49-F238E27FC236}">
-                <a16:creationId xmlns:a16="http://schemas.microsoft.com/office/drawing/2014/main" id="{18F1C948-7C42-4D4C-9F56-57C5D4365075}"/>
+                <a16:creationId xmlns:a16="http://schemas.microsoft.com/office/drawing/2014/main" id="{FF589A52-F175-48CF-8D47-99AD63EE35F3}"/>
               </a:ext>
             </a:extLst>
           </p:cNvPr>
@@ -7285,7 +7285,7 @@
           <p:nvPr/>
         </p:nvPicPr>
         <p:blipFill>
-          <a:blip xmlns:r="http://schemas.openxmlformats.org/officeDocument/2006/relationships" xmlns:a="http://schemas.openxmlformats.org/drawingml/2006/main" r:embed="Ra4cc91e498cf49b3"/>
+          <a:blip xmlns:r="http://schemas.openxmlformats.org/officeDocument/2006/relationships" xmlns:a="http://schemas.openxmlformats.org/drawingml/2006/main" r:embed="R9ee420aa9f854c9e"/>
           <a:stretch xmlns:a="http://schemas.openxmlformats.org/drawingml/2006/main"/>
         </p:blipFill>
         <p:spPr>
@@ -7301,7 +7301,7 @@
     </p:spTree>
     <p:extLst>
       <p:ext uri="{BB962C8B-B14F-4D97-AF65-F5344CB8AC3E}">
-        <p14:creationId xmlns:p14="http://schemas.microsoft.com/office/powerpoint/2010/main" val="615098568"/>
+        <p14:creationId xmlns:p14="http://schemas.microsoft.com/office/powerpoint/2010/main" val="1062306314"/>
       </p:ext>
     </p:extLst>
   </p:cSld>
@@ -7325,7 +7325,7 @@
           <p:cNvPr id="2" name="">
             <a:extLst xmlns:a="http://schemas.openxmlformats.org/drawingml/2006/main">
               <a:ext uri="{FF2B5EF4-FFF2-40B4-BE49-F238E27FC236}">
-                <a16:creationId xmlns:a16="http://schemas.microsoft.com/office/drawing/2014/main" id="{CC7E0602-F0D5-433D-AFAC-2ABF11CACB2C}"/>
+                <a16:creationId xmlns:a16="http://schemas.microsoft.com/office/drawing/2014/main" id="{467E4D84-8608-44E3-AAC2-473195ECC554}"/>
               </a:ext>
             </a:extLst>
           </p:cNvPr>
@@ -7335,7 +7335,7 @@
           <p:nvPr/>
         </p:nvPicPr>
         <p:blipFill>
-          <a:blip xmlns:r="http://schemas.openxmlformats.org/officeDocument/2006/relationships" xmlns:a="http://schemas.openxmlformats.org/drawingml/2006/main" r:embed="R8fcc6e4a65a740d8"/>
+          <a:blip xmlns:r="http://schemas.openxmlformats.org/officeDocument/2006/relationships" xmlns:a="http://schemas.openxmlformats.org/drawingml/2006/main" r:embed="R098979e448824895"/>
           <a:stretch xmlns:a="http://schemas.openxmlformats.org/drawingml/2006/main"/>
         </p:blipFill>
         <p:spPr>
@@ -7351,7 +7351,7 @@
     </p:spTree>
     <p:extLst>
       <p:ext uri="{BB962C8B-B14F-4D97-AF65-F5344CB8AC3E}">
-        <p14:creationId xmlns:p14="http://schemas.microsoft.com/office/powerpoint/2010/main" val="1528002657"/>
+        <p14:creationId xmlns:p14="http://schemas.microsoft.com/office/powerpoint/2010/main" val="126725741"/>
       </p:ext>
     </p:extLst>
   </p:cSld>
@@ -7375,7 +7375,7 @@
           <p:cNvPr id="2" name="">
             <a:extLst xmlns:a="http://schemas.openxmlformats.org/drawingml/2006/main">
               <a:ext uri="{FF2B5EF4-FFF2-40B4-BE49-F238E27FC236}">
-                <a16:creationId xmlns:a16="http://schemas.microsoft.com/office/drawing/2014/main" id="{9708FD25-C0C0-4D00-930E-AECA56E36834}"/>
+                <a16:creationId xmlns:a16="http://schemas.microsoft.com/office/drawing/2014/main" id="{3B0E34EC-559C-4DB0-A4FF-9E20238FE6CA}"/>
               </a:ext>
             </a:extLst>
           </p:cNvPr>
@@ -7385,7 +7385,7 @@
           <p:nvPr/>
         </p:nvPicPr>
         <p:blipFill>
-          <a:blip xmlns:r="http://schemas.openxmlformats.org/officeDocument/2006/relationships" xmlns:a="http://schemas.openxmlformats.org/drawingml/2006/main" r:embed="R989a3b125d95498c"/>
+          <a:blip xmlns:r="http://schemas.openxmlformats.org/officeDocument/2006/relationships" xmlns:a="http://schemas.openxmlformats.org/drawingml/2006/main" r:embed="R6fe78c1013f54ba1"/>
           <a:stretch xmlns:a="http://schemas.openxmlformats.org/drawingml/2006/main"/>
         </p:blipFill>
         <p:spPr>
@@ -7401,7 +7401,7 @@
     </p:spTree>
     <p:extLst>
       <p:ext uri="{BB962C8B-B14F-4D97-AF65-F5344CB8AC3E}">
-        <p14:creationId xmlns:p14="http://schemas.microsoft.com/office/powerpoint/2010/main" val="1377683802"/>
+        <p14:creationId xmlns:p14="http://schemas.microsoft.com/office/powerpoint/2010/main" val="1611762864"/>
       </p:ext>
     </p:extLst>
   </p:cSld>
@@ -7425,7 +7425,7 @@
           <p:cNvPr id="2" name="">
             <a:extLst xmlns:a="http://schemas.openxmlformats.org/drawingml/2006/main">
               <a:ext uri="{FF2B5EF4-FFF2-40B4-BE49-F238E27FC236}">
-                <a16:creationId xmlns:a16="http://schemas.microsoft.com/office/drawing/2014/main" id="{2302EE8E-F310-41AE-9602-10E6D1519652}"/>
+                <a16:creationId xmlns:a16="http://schemas.microsoft.com/office/drawing/2014/main" id="{5C0940DE-63EC-41B0-8DCF-047F4F877750}"/>
               </a:ext>
             </a:extLst>
           </p:cNvPr>
@@ -7435,7 +7435,7 @@
           <p:nvPr/>
         </p:nvPicPr>
         <p:blipFill>
-          <a:blip xmlns:r="http://schemas.openxmlformats.org/officeDocument/2006/relationships" xmlns:a="http://schemas.openxmlformats.org/drawingml/2006/main" r:embed="R604de42d34014c7d"/>
+          <a:blip xmlns:r="http://schemas.openxmlformats.org/officeDocument/2006/relationships" xmlns:a="http://schemas.openxmlformats.org/drawingml/2006/main" r:embed="Ra43442ac7a1d436a"/>
           <a:stretch xmlns:a="http://schemas.openxmlformats.org/drawingml/2006/main"/>
         </p:blipFill>
         <p:spPr>
@@ -7451,7 +7451,7 @@
     </p:spTree>
     <p:extLst>
       <p:ext uri="{BB962C8B-B14F-4D97-AF65-F5344CB8AC3E}">
-        <p14:creationId xmlns:p14="http://schemas.microsoft.com/office/powerpoint/2010/main" val="2050252709"/>
+        <p14:creationId xmlns:p14="http://schemas.microsoft.com/office/powerpoint/2010/main" val="1946253017"/>
       </p:ext>
     </p:extLst>
   </p:cSld>
@@ -7475,7 +7475,7 @@
           <p:cNvPr id="2" name="">
             <a:extLst xmlns:a="http://schemas.openxmlformats.org/drawingml/2006/main">
               <a:ext uri="{FF2B5EF4-FFF2-40B4-BE49-F238E27FC236}">
-                <a16:creationId xmlns:a16="http://schemas.microsoft.com/office/drawing/2014/main" id="{89D6EF7E-32A3-48F3-82D0-28A815F804A2}"/>
+                <a16:creationId xmlns:a16="http://schemas.microsoft.com/office/drawing/2014/main" id="{C33CA065-CFE1-43B8-B0BB-EAAA3034C339}"/>
               </a:ext>
             </a:extLst>
           </p:cNvPr>
@@ -7485,7 +7485,7 @@
           <p:nvPr/>
         </p:nvPicPr>
         <p:blipFill>
-          <a:blip xmlns:r="http://schemas.openxmlformats.org/officeDocument/2006/relationships" xmlns:a="http://schemas.openxmlformats.org/drawingml/2006/main" r:embed="R95f043b25b304431"/>
+          <a:blip xmlns:r="http://schemas.openxmlformats.org/officeDocument/2006/relationships" xmlns:a="http://schemas.openxmlformats.org/drawingml/2006/main" r:embed="Re22173731dba44cb"/>
           <a:stretch xmlns:a="http://schemas.openxmlformats.org/drawingml/2006/main"/>
         </p:blipFill>
         <p:spPr>
@@ -7501,7 +7501,7 @@
     </p:spTree>
     <p:extLst>
       <p:ext uri="{BB962C8B-B14F-4D97-AF65-F5344CB8AC3E}">
-        <p14:creationId xmlns:p14="http://schemas.microsoft.com/office/powerpoint/2010/main" val="1340104102"/>
+        <p14:creationId xmlns:p14="http://schemas.microsoft.com/office/powerpoint/2010/main" val="1323209826"/>
       </p:ext>
     </p:extLst>
   </p:cSld>
@@ -7525,7 +7525,7 @@
           <p:cNvPr id="2" name="">
             <a:extLst xmlns:a="http://schemas.openxmlformats.org/drawingml/2006/main">
               <a:ext uri="{FF2B5EF4-FFF2-40B4-BE49-F238E27FC236}">
-                <a16:creationId xmlns:a16="http://schemas.microsoft.com/office/drawing/2014/main" id="{65E571CD-B1BA-4B70-B0FF-A4418ADE4957}"/>
+                <a16:creationId xmlns:a16="http://schemas.microsoft.com/office/drawing/2014/main" id="{F70F508B-C2B0-4F74-AB36-4F5A3F256614}"/>
               </a:ext>
             </a:extLst>
           </p:cNvPr>
@@ -7535,7 +7535,7 @@
           <p:nvPr/>
         </p:nvPicPr>
         <p:blipFill>
-          <a:blip xmlns:r="http://schemas.openxmlformats.org/officeDocument/2006/relationships" xmlns:a="http://schemas.openxmlformats.org/drawingml/2006/main" r:embed="Rc20630fa475747bb"/>
+          <a:blip xmlns:r="http://schemas.openxmlformats.org/officeDocument/2006/relationships" xmlns:a="http://schemas.openxmlformats.org/drawingml/2006/main" r:embed="R90d3b86478ff443e"/>
           <a:stretch xmlns:a="http://schemas.openxmlformats.org/drawingml/2006/main"/>
         </p:blipFill>
         <p:spPr>
@@ -7551,7 +7551,7 @@
     </p:spTree>
     <p:extLst>
       <p:ext uri="{BB962C8B-B14F-4D97-AF65-F5344CB8AC3E}">
-        <p14:creationId xmlns:p14="http://schemas.microsoft.com/office/powerpoint/2010/main" val="1200192484"/>
+        <p14:creationId xmlns:p14="http://schemas.microsoft.com/office/powerpoint/2010/main" val="981313792"/>
       </p:ext>
     </p:extLst>
   </p:cSld>
@@ -7575,7 +7575,7 @@
           <p:cNvPr id="2" name="">
             <a:extLst xmlns:a="http://schemas.openxmlformats.org/drawingml/2006/main">
               <a:ext uri="{FF2B5EF4-FFF2-40B4-BE49-F238E27FC236}">
-                <a16:creationId xmlns:a16="http://schemas.microsoft.com/office/drawing/2014/main" id="{C153CB0B-64A8-4000-82A3-59771F09A4A0}"/>
+                <a16:creationId xmlns:a16="http://schemas.microsoft.com/office/drawing/2014/main" id="{EF333B66-4DAB-40B8-8FDB-CD427954E0DA}"/>
               </a:ext>
             </a:extLst>
           </p:cNvPr>
@@ -7585,7 +7585,7 @@
           <p:nvPr/>
         </p:nvPicPr>
         <p:blipFill>
-          <a:blip xmlns:r="http://schemas.openxmlformats.org/officeDocument/2006/relationships" xmlns:a="http://schemas.openxmlformats.org/drawingml/2006/main" r:embed="Re3fc016040134ff3"/>
+          <a:blip xmlns:r="http://schemas.openxmlformats.org/officeDocument/2006/relationships" xmlns:a="http://schemas.openxmlformats.org/drawingml/2006/main" r:embed="R4d4b3d5a6de2451a"/>
           <a:stretch xmlns:a="http://schemas.openxmlformats.org/drawingml/2006/main"/>
         </p:blipFill>
         <p:spPr>
@@ -7601,7 +7601,7 @@
     </p:spTree>
     <p:extLst>
       <p:ext uri="{BB962C8B-B14F-4D97-AF65-F5344CB8AC3E}">
-        <p14:creationId xmlns:p14="http://schemas.microsoft.com/office/powerpoint/2010/main" val="1149050775"/>
+        <p14:creationId xmlns:p14="http://schemas.microsoft.com/office/powerpoint/2010/main" val="965524633"/>
       </p:ext>
     </p:extLst>
   </p:cSld>
@@ -7625,7 +7625,7 @@
           <p:cNvPr id="2" name="">
             <a:extLst xmlns:a="http://schemas.openxmlformats.org/drawingml/2006/main">
               <a:ext uri="{FF2B5EF4-FFF2-40B4-BE49-F238E27FC236}">
-                <a16:creationId xmlns:a16="http://schemas.microsoft.com/office/drawing/2014/main" id="{39B94570-AA02-4494-9AB3-922E6154AAAF}"/>
+                <a16:creationId xmlns:a16="http://schemas.microsoft.com/office/drawing/2014/main" id="{0A375572-7CCD-44A7-B592-314687806001}"/>
               </a:ext>
             </a:extLst>
           </p:cNvPr>
@@ -7635,7 +7635,7 @@
           <p:nvPr/>
         </p:nvPicPr>
         <p:blipFill>
-          <a:blip xmlns:r="http://schemas.openxmlformats.org/officeDocument/2006/relationships" xmlns:a="http://schemas.openxmlformats.org/drawingml/2006/main" r:embed="R809ef47e378d4115"/>
+          <a:blip xmlns:r="http://schemas.openxmlformats.org/officeDocument/2006/relationships" xmlns:a="http://schemas.openxmlformats.org/drawingml/2006/main" r:embed="Re4497d1c2ea644c8"/>
           <a:stretch xmlns:a="http://schemas.openxmlformats.org/drawingml/2006/main"/>
         </p:blipFill>
         <p:spPr>
@@ -7651,7 +7651,7 @@
     </p:spTree>
     <p:extLst>
       <p:ext uri="{BB962C8B-B14F-4D97-AF65-F5344CB8AC3E}">
-        <p14:creationId xmlns:p14="http://schemas.microsoft.com/office/powerpoint/2010/main" val="1066350706"/>
+        <p14:creationId xmlns:p14="http://schemas.microsoft.com/office/powerpoint/2010/main" val="929993227"/>
       </p:ext>
     </p:extLst>
   </p:cSld>
@@ -7675,7 +7675,7 @@
           <p:cNvPr id="2" name="">
             <a:extLst xmlns:a="http://schemas.openxmlformats.org/drawingml/2006/main">
               <a:ext uri="{FF2B5EF4-FFF2-40B4-BE49-F238E27FC236}">
-                <a16:creationId xmlns:a16="http://schemas.microsoft.com/office/drawing/2014/main" id="{E740FC08-F16E-4C2A-A09B-904E1E4A76C7}"/>
+                <a16:creationId xmlns:a16="http://schemas.microsoft.com/office/drawing/2014/main" id="{536F0B1A-3209-4E49-8AF2-E9FE10A1989E}"/>
               </a:ext>
             </a:extLst>
           </p:cNvPr>
@@ -7685,7 +7685,7 @@
           <p:nvPr/>
         </p:nvPicPr>
         <p:blipFill>
-          <a:blip xmlns:r="http://schemas.openxmlformats.org/officeDocument/2006/relationships" xmlns:a="http://schemas.openxmlformats.org/drawingml/2006/main" r:embed="R225a6f2be2574361"/>
+          <a:blip xmlns:r="http://schemas.openxmlformats.org/officeDocument/2006/relationships" xmlns:a="http://schemas.openxmlformats.org/drawingml/2006/main" r:embed="R4939dde0ecec4c6d"/>
           <a:stretch xmlns:a="http://schemas.openxmlformats.org/drawingml/2006/main"/>
         </p:blipFill>
         <p:spPr>
@@ -7701,7 +7701,7 @@
     </p:spTree>
     <p:extLst>
       <p:ext uri="{BB962C8B-B14F-4D97-AF65-F5344CB8AC3E}">
-        <p14:creationId xmlns:p14="http://schemas.microsoft.com/office/powerpoint/2010/main" val="930463080"/>
+        <p14:creationId xmlns:p14="http://schemas.microsoft.com/office/powerpoint/2010/main" val="1935373792"/>
       </p:ext>
     </p:extLst>
   </p:cSld>
@@ -7725,7 +7725,7 @@
           <p:cNvPr id="2" name="">
             <a:extLst xmlns:a="http://schemas.openxmlformats.org/drawingml/2006/main">
               <a:ext uri="{FF2B5EF4-FFF2-40B4-BE49-F238E27FC236}">
-                <a16:creationId xmlns:a16="http://schemas.microsoft.com/office/drawing/2014/main" id="{BC6D3A00-9B3C-403E-9D3B-B10E816CA86C}"/>
+                <a16:creationId xmlns:a16="http://schemas.microsoft.com/office/drawing/2014/main" id="{F3056C05-3ACA-44E8-BAF7-1E23DCEC500E}"/>
               </a:ext>
             </a:extLst>
           </p:cNvPr>
@@ -7735,7 +7735,7 @@
           <p:nvPr/>
         </p:nvPicPr>
         <p:blipFill>
-          <a:blip xmlns:r="http://schemas.openxmlformats.org/officeDocument/2006/relationships" xmlns:a="http://schemas.openxmlformats.org/drawingml/2006/main" r:embed="R886aa5d5163e479f"/>
+          <a:blip xmlns:r="http://schemas.openxmlformats.org/officeDocument/2006/relationships" xmlns:a="http://schemas.openxmlformats.org/drawingml/2006/main" r:embed="R3d8fcde613dd4c9a"/>
           <a:stretch xmlns:a="http://schemas.openxmlformats.org/drawingml/2006/main"/>
         </p:blipFill>
         <p:spPr>
@@ -7751,7 +7751,7 @@
     </p:spTree>
     <p:extLst>
       <p:ext uri="{BB962C8B-B14F-4D97-AF65-F5344CB8AC3E}">
-        <p14:creationId xmlns:p14="http://schemas.microsoft.com/office/powerpoint/2010/main" val="243431418"/>
+        <p14:creationId xmlns:p14="http://schemas.microsoft.com/office/powerpoint/2010/main" val="35666833"/>
       </p:ext>
     </p:extLst>
   </p:cSld>
@@ -7775,7 +7775,7 @@
           <p:cNvPr id="2" name="">
             <a:extLst xmlns:a="http://schemas.openxmlformats.org/drawingml/2006/main">
               <a:ext uri="{FF2B5EF4-FFF2-40B4-BE49-F238E27FC236}">
-                <a16:creationId xmlns:a16="http://schemas.microsoft.com/office/drawing/2014/main" id="{C9D7EB98-BB6C-4995-9FB9-DA0934A5DBC5}"/>
+                <a16:creationId xmlns:a16="http://schemas.microsoft.com/office/drawing/2014/main" id="{A6D9A042-DE40-4A84-86C1-129B4E5D8B29}"/>
               </a:ext>
             </a:extLst>
           </p:cNvPr>
@@ -7785,7 +7785,7 @@
           <p:nvPr/>
         </p:nvPicPr>
         <p:blipFill>
-          <a:blip xmlns:r="http://schemas.openxmlformats.org/officeDocument/2006/relationships" xmlns:a="http://schemas.openxmlformats.org/drawingml/2006/main" r:embed="R6610206a823b4b10"/>
+          <a:blip xmlns:r="http://schemas.openxmlformats.org/officeDocument/2006/relationships" xmlns:a="http://schemas.openxmlformats.org/drawingml/2006/main" r:embed="R24ccae8755a04430"/>
           <a:stretch xmlns:a="http://schemas.openxmlformats.org/drawingml/2006/main"/>
         </p:blipFill>
         <p:spPr>
@@ -7801,7 +7801,7 @@
     </p:spTree>
     <p:extLst>
       <p:ext uri="{BB962C8B-B14F-4D97-AF65-F5344CB8AC3E}">
-        <p14:creationId xmlns:p14="http://schemas.microsoft.com/office/powerpoint/2010/main" val="106518143"/>
+        <p14:creationId xmlns:p14="http://schemas.microsoft.com/office/powerpoint/2010/main" val="386954444"/>
       </p:ext>
     </p:extLst>
   </p:cSld>
@@ -7825,7 +7825,7 @@
           <p:cNvPr id="2" name="">
             <a:extLst xmlns:a="http://schemas.openxmlformats.org/drawingml/2006/main">
               <a:ext uri="{FF2B5EF4-FFF2-40B4-BE49-F238E27FC236}">
-                <a16:creationId xmlns:a16="http://schemas.microsoft.com/office/drawing/2014/main" id="{42ED0262-76BB-4EC6-891D-F48564E93245}"/>
+                <a16:creationId xmlns:a16="http://schemas.microsoft.com/office/drawing/2014/main" id="{01B0BCFB-46B4-4D86-A6CA-6399E18DA78C}"/>
               </a:ext>
             </a:extLst>
           </p:cNvPr>
@@ -7835,7 +7835,7 @@
           <p:nvPr/>
         </p:nvPicPr>
         <p:blipFill>
-          <a:blip xmlns:r="http://schemas.openxmlformats.org/officeDocument/2006/relationships" xmlns:a="http://schemas.openxmlformats.org/drawingml/2006/main" r:embed="R2651b264893f4c27"/>
+          <a:blip xmlns:r="http://schemas.openxmlformats.org/officeDocument/2006/relationships" xmlns:a="http://schemas.openxmlformats.org/drawingml/2006/main" r:embed="Rccb47b340bc54d86"/>
           <a:stretch xmlns:a="http://schemas.openxmlformats.org/drawingml/2006/main"/>
         </p:blipFill>
         <p:spPr>
@@ -7851,7 +7851,7 @@
     </p:spTree>
     <p:extLst>
       <p:ext uri="{BB962C8B-B14F-4D97-AF65-F5344CB8AC3E}">
-        <p14:creationId xmlns:p14="http://schemas.microsoft.com/office/powerpoint/2010/main" val="1506859425"/>
+        <p14:creationId xmlns:p14="http://schemas.microsoft.com/office/powerpoint/2010/main" val="1815424753"/>
       </p:ext>
     </p:extLst>
   </p:cSld>
@@ -7875,7 +7875,7 @@
           <p:cNvPr id="2" name="">
             <a:extLst xmlns:a="http://schemas.openxmlformats.org/drawingml/2006/main">
               <a:ext uri="{FF2B5EF4-FFF2-40B4-BE49-F238E27FC236}">
-                <a16:creationId xmlns:a16="http://schemas.microsoft.com/office/drawing/2014/main" id="{B1DAE57D-0B1D-4765-A3EB-A76DBE6CF05E}"/>
+                <a16:creationId xmlns:a16="http://schemas.microsoft.com/office/drawing/2014/main" id="{2346E97A-880D-4CF3-9A6B-1EA60940FEA1}"/>
               </a:ext>
             </a:extLst>
           </p:cNvPr>
@@ -7885,7 +7885,7 @@
           <p:nvPr/>
         </p:nvPicPr>
         <p:blipFill>
-          <a:blip xmlns:r="http://schemas.openxmlformats.org/officeDocument/2006/relationships" xmlns:a="http://schemas.openxmlformats.org/drawingml/2006/main" r:embed="R81ae99bd06194b63"/>
+          <a:blip xmlns:r="http://schemas.openxmlformats.org/officeDocument/2006/relationships" xmlns:a="http://schemas.openxmlformats.org/drawingml/2006/main" r:embed="Rc2331b6c5aa64013"/>
           <a:stretch xmlns:a="http://schemas.openxmlformats.org/drawingml/2006/main"/>
         </p:blipFill>
         <p:spPr>
@@ -7901,7 +7901,7 @@
     </p:spTree>
     <p:extLst>
       <p:ext uri="{BB962C8B-B14F-4D97-AF65-F5344CB8AC3E}">
-        <p14:creationId xmlns:p14="http://schemas.microsoft.com/office/powerpoint/2010/main" val="271262879"/>
+        <p14:creationId xmlns:p14="http://schemas.microsoft.com/office/powerpoint/2010/main" val="976840321"/>
       </p:ext>
     </p:extLst>
   </p:cSld>
@@ -7925,7 +7925,7 @@
           <p:cNvPr id="2" name="">
             <a:extLst xmlns:a="http://schemas.openxmlformats.org/drawingml/2006/main">
               <a:ext uri="{FF2B5EF4-FFF2-40B4-BE49-F238E27FC236}">
-                <a16:creationId xmlns:a16="http://schemas.microsoft.com/office/drawing/2014/main" id="{3C8DD8AF-9BF2-4715-A4A8-1DB7E614222B}"/>
+                <a16:creationId xmlns:a16="http://schemas.microsoft.com/office/drawing/2014/main" id="{87C15964-C622-4F6B-9F28-488D0D535359}"/>
               </a:ext>
             </a:extLst>
           </p:cNvPr>
@@ -7935,7 +7935,7 @@
           <p:nvPr/>
         </p:nvPicPr>
         <p:blipFill>
-          <a:blip xmlns:r="http://schemas.openxmlformats.org/officeDocument/2006/relationships" xmlns:a="http://schemas.openxmlformats.org/drawingml/2006/main" r:embed="R40ec0824b825448b"/>
+          <a:blip xmlns:r="http://schemas.openxmlformats.org/officeDocument/2006/relationships" xmlns:a="http://schemas.openxmlformats.org/drawingml/2006/main" r:embed="Ra2eb12a42c2f4d41"/>
           <a:stretch xmlns:a="http://schemas.openxmlformats.org/drawingml/2006/main"/>
         </p:blipFill>
         <p:spPr>
@@ -7951,7 +7951,7 @@
     </p:spTree>
     <p:extLst>
       <p:ext uri="{BB962C8B-B14F-4D97-AF65-F5344CB8AC3E}">
-        <p14:creationId xmlns:p14="http://schemas.microsoft.com/office/powerpoint/2010/main" val="431396000"/>
+        <p14:creationId xmlns:p14="http://schemas.microsoft.com/office/powerpoint/2010/main" val="269007755"/>
       </p:ext>
     </p:extLst>
   </p:cSld>
@@ -7975,7 +7975,7 @@
           <p:cNvPr id="2" name="">
             <a:extLst xmlns:a="http://schemas.openxmlformats.org/drawingml/2006/main">
               <a:ext uri="{FF2B5EF4-FFF2-40B4-BE49-F238E27FC236}">
-                <a16:creationId xmlns:a16="http://schemas.microsoft.com/office/drawing/2014/main" id="{FBCE621E-6452-4A23-BA6D-E00ACDEB3A3E}"/>
+                <a16:creationId xmlns:a16="http://schemas.microsoft.com/office/drawing/2014/main" id="{3A1BF246-49E5-4378-87E0-BA459E55CD7A}"/>
               </a:ext>
             </a:extLst>
           </p:cNvPr>
@@ -7985,7 +7985,7 @@
           <p:nvPr/>
         </p:nvPicPr>
         <p:blipFill>
-          <a:blip xmlns:r="http://schemas.openxmlformats.org/officeDocument/2006/relationships" xmlns:a="http://schemas.openxmlformats.org/drawingml/2006/main" r:embed="R9a9bd3e0f1764832"/>
+          <a:blip xmlns:r="http://schemas.openxmlformats.org/officeDocument/2006/relationships" xmlns:a="http://schemas.openxmlformats.org/drawingml/2006/main" r:embed="Rfe7878a341354657"/>
           <a:stretch xmlns:a="http://schemas.openxmlformats.org/drawingml/2006/main"/>
         </p:blipFill>
         <p:spPr>
@@ -8001,7 +8001,7 @@
     </p:spTree>
     <p:extLst>
       <p:ext uri="{BB962C8B-B14F-4D97-AF65-F5344CB8AC3E}">
-        <p14:creationId xmlns:p14="http://schemas.microsoft.com/office/powerpoint/2010/main" val="795562573"/>
+        <p14:creationId xmlns:p14="http://schemas.microsoft.com/office/powerpoint/2010/main" val="562520599"/>
       </p:ext>
     </p:extLst>
   </p:cSld>
@@ -8025,7 +8025,7 @@
           <p:cNvPr id="2" name="">
             <a:extLst xmlns:a="http://schemas.openxmlformats.org/drawingml/2006/main">
               <a:ext uri="{FF2B5EF4-FFF2-40B4-BE49-F238E27FC236}">
-                <a16:creationId xmlns:a16="http://schemas.microsoft.com/office/drawing/2014/main" id="{71C5017F-1E8A-4042-A4DF-D9937E904CCA}"/>
+                <a16:creationId xmlns:a16="http://schemas.microsoft.com/office/drawing/2014/main" id="{1C4B7379-39A3-4275-BD4A-FA55CE572761}"/>
               </a:ext>
             </a:extLst>
           </p:cNvPr>
@@ -8035,7 +8035,7 @@
           <p:nvPr/>
         </p:nvPicPr>
         <p:blipFill>
-          <a:blip xmlns:r="http://schemas.openxmlformats.org/officeDocument/2006/relationships" xmlns:a="http://schemas.openxmlformats.org/drawingml/2006/main" r:embed="R761e68ddb5184f77"/>
+          <a:blip xmlns:r="http://schemas.openxmlformats.org/officeDocument/2006/relationships" xmlns:a="http://schemas.openxmlformats.org/drawingml/2006/main" r:embed="R75ab0ccf604741ee"/>
           <a:stretch xmlns:a="http://schemas.openxmlformats.org/drawingml/2006/main"/>
         </p:blipFill>
         <p:spPr>
@@ -8051,7 +8051,7 @@
     </p:spTree>
     <p:extLst>
       <p:ext uri="{BB962C8B-B14F-4D97-AF65-F5344CB8AC3E}">
-        <p14:creationId xmlns:p14="http://schemas.microsoft.com/office/powerpoint/2010/main" val="824163855"/>
+        <p14:creationId xmlns:p14="http://schemas.microsoft.com/office/powerpoint/2010/main" val="1587940061"/>
       </p:ext>
     </p:extLst>
   </p:cSld>
@@ -8075,7 +8075,7 @@
           <p:cNvPr id="2" name="">
             <a:extLst xmlns:a="http://schemas.openxmlformats.org/drawingml/2006/main">
               <a:ext uri="{FF2B5EF4-FFF2-40B4-BE49-F238E27FC236}">
-                <a16:creationId xmlns:a16="http://schemas.microsoft.com/office/drawing/2014/main" id="{81F800E6-73B2-4212-862D-7CFBD248C6DC}"/>
+                <a16:creationId xmlns:a16="http://schemas.microsoft.com/office/drawing/2014/main" id="{7C02171A-96AB-4DE4-B40A-B9DAF602CCD4}"/>
               </a:ext>
             </a:extLst>
           </p:cNvPr>
@@ -8085,7 +8085,7 @@
           <p:nvPr/>
         </p:nvPicPr>
         <p:blipFill>
-          <a:blip xmlns:r="http://schemas.openxmlformats.org/officeDocument/2006/relationships" xmlns:a="http://schemas.openxmlformats.org/drawingml/2006/main" r:embed="Rb510dfd5b0ab4cee"/>
+          <a:blip xmlns:r="http://schemas.openxmlformats.org/officeDocument/2006/relationships" xmlns:a="http://schemas.openxmlformats.org/drawingml/2006/main" r:embed="R72c8815a37114df9"/>
           <a:stretch xmlns:a="http://schemas.openxmlformats.org/drawingml/2006/main"/>
         </p:blipFill>
         <p:spPr>
@@ -8101,7 +8101,7 @@
     </p:spTree>
     <p:extLst>
       <p:ext uri="{BB962C8B-B14F-4D97-AF65-F5344CB8AC3E}">
-        <p14:creationId xmlns:p14="http://schemas.microsoft.com/office/powerpoint/2010/main" val="1374284958"/>
+        <p14:creationId xmlns:p14="http://schemas.microsoft.com/office/powerpoint/2010/main" val="1975559188"/>
       </p:ext>
     </p:extLst>
   </p:cSld>
@@ -8125,7 +8125,7 @@
           <p:cNvPr id="2" name="">
             <a:extLst xmlns:a="http://schemas.openxmlformats.org/drawingml/2006/main">
               <a:ext uri="{FF2B5EF4-FFF2-40B4-BE49-F238E27FC236}">
-                <a16:creationId xmlns:a16="http://schemas.microsoft.com/office/drawing/2014/main" id="{1CC0AE92-4867-4336-876E-C1C34438AC9B}"/>
+                <a16:creationId xmlns:a16="http://schemas.microsoft.com/office/drawing/2014/main" id="{63074B55-808C-46B0-A3A5-8A6B3A30DA35}"/>
               </a:ext>
             </a:extLst>
           </p:cNvPr>
@@ -8135,7 +8135,7 @@
           <p:nvPr/>
         </p:nvPicPr>
         <p:blipFill>
-          <a:blip xmlns:r="http://schemas.openxmlformats.org/officeDocument/2006/relationships" xmlns:a="http://schemas.openxmlformats.org/drawingml/2006/main" r:embed="R904cb27a2cc143f0"/>
+          <a:blip xmlns:r="http://schemas.openxmlformats.org/officeDocument/2006/relationships" xmlns:a="http://schemas.openxmlformats.org/drawingml/2006/main" r:embed="R63aa375ec0a64367"/>
           <a:stretch xmlns:a="http://schemas.openxmlformats.org/drawingml/2006/main"/>
         </p:blipFill>
         <p:spPr>
@@ -8151,7 +8151,7 @@
     </p:spTree>
     <p:extLst>
       <p:ext uri="{BB962C8B-B14F-4D97-AF65-F5344CB8AC3E}">
-        <p14:creationId xmlns:p14="http://schemas.microsoft.com/office/powerpoint/2010/main" val="504745213"/>
+        <p14:creationId xmlns:p14="http://schemas.microsoft.com/office/powerpoint/2010/main" val="134065753"/>
       </p:ext>
     </p:extLst>
   </p:cSld>
@@ -8175,7 +8175,7 @@
           <p:cNvPr id="2" name="">
             <a:extLst xmlns:a="http://schemas.openxmlformats.org/drawingml/2006/main">
               <a:ext uri="{FF2B5EF4-FFF2-40B4-BE49-F238E27FC236}">
-                <a16:creationId xmlns:a16="http://schemas.microsoft.com/office/drawing/2014/main" id="{A4EA3D53-4CC9-4A9C-96CF-20E043702CA4}"/>
+                <a16:creationId xmlns:a16="http://schemas.microsoft.com/office/drawing/2014/main" id="{5747E944-FE6A-43FC-A69A-8B8CAED9CFA0}"/>
               </a:ext>
             </a:extLst>
           </p:cNvPr>
@@ -8185,7 +8185,7 @@
           <p:nvPr/>
         </p:nvPicPr>
         <p:blipFill>
-          <a:blip xmlns:r="http://schemas.openxmlformats.org/officeDocument/2006/relationships" xmlns:a="http://schemas.openxmlformats.org/drawingml/2006/main" r:embed="R58f704f8c7ce473f"/>
+          <a:blip xmlns:r="http://schemas.openxmlformats.org/officeDocument/2006/relationships" xmlns:a="http://schemas.openxmlformats.org/drawingml/2006/main" r:embed="R1c2d083e170b48e3"/>
           <a:stretch xmlns:a="http://schemas.openxmlformats.org/drawingml/2006/main"/>
         </p:blipFill>
         <p:spPr>
@@ -8201,7 +8201,7 @@
     </p:spTree>
     <p:extLst>
       <p:ext uri="{BB962C8B-B14F-4D97-AF65-F5344CB8AC3E}">
-        <p14:creationId xmlns:p14="http://schemas.microsoft.com/office/powerpoint/2010/main" val="641552671"/>
+        <p14:creationId xmlns:p14="http://schemas.microsoft.com/office/powerpoint/2010/main" val="1866776707"/>
       </p:ext>
     </p:extLst>
   </p:cSld>
@@ -8225,7 +8225,7 @@
           <p:cNvPr id="2" name="">
             <a:extLst xmlns:a="http://schemas.openxmlformats.org/drawingml/2006/main">
               <a:ext uri="{FF2B5EF4-FFF2-40B4-BE49-F238E27FC236}">
-                <a16:creationId xmlns:a16="http://schemas.microsoft.com/office/drawing/2014/main" id="{97466CA1-B901-4CF8-989B-76CEEEF467D0}"/>
+                <a16:creationId xmlns:a16="http://schemas.microsoft.com/office/drawing/2014/main" id="{6261833B-9A89-4F22-A4B1-B071CE7360C8}"/>
               </a:ext>
             </a:extLst>
           </p:cNvPr>
@@ -8235,7 +8235,7 @@
           <p:nvPr/>
         </p:nvPicPr>
         <p:blipFill>
-          <a:blip xmlns:r="http://schemas.openxmlformats.org/officeDocument/2006/relationships" xmlns:a="http://schemas.openxmlformats.org/drawingml/2006/main" r:embed="R804af969c9f34a5d"/>
+          <a:blip xmlns:r="http://schemas.openxmlformats.org/officeDocument/2006/relationships" xmlns:a="http://schemas.openxmlformats.org/drawingml/2006/main" r:embed="Rd5913f1e96f94c5b"/>
           <a:stretch xmlns:a="http://schemas.openxmlformats.org/drawingml/2006/main"/>
         </p:blipFill>
         <p:spPr>
@@ -8251,7 +8251,7 @@
     </p:spTree>
     <p:extLst>
       <p:ext uri="{BB962C8B-B14F-4D97-AF65-F5344CB8AC3E}">
-        <p14:creationId xmlns:p14="http://schemas.microsoft.com/office/powerpoint/2010/main" val="1447680306"/>
+        <p14:creationId xmlns:p14="http://schemas.microsoft.com/office/powerpoint/2010/main" val="2143056922"/>
       </p:ext>
     </p:extLst>
   </p:cSld>
@@ -8275,7 +8275,7 @@
           <p:cNvPr id="2" name="">
             <a:extLst xmlns:a="http://schemas.openxmlformats.org/drawingml/2006/main">
               <a:ext uri="{FF2B5EF4-FFF2-40B4-BE49-F238E27FC236}">
-                <a16:creationId xmlns:a16="http://schemas.microsoft.com/office/drawing/2014/main" id="{A527B719-3E9C-4E76-8FC1-282C40833324}"/>
+                <a16:creationId xmlns:a16="http://schemas.microsoft.com/office/drawing/2014/main" id="{521144E1-F363-4DA2-B8B6-C353395CF9CC}"/>
               </a:ext>
             </a:extLst>
           </p:cNvPr>
@@ -8285,7 +8285,7 @@
           <p:nvPr/>
         </p:nvPicPr>
         <p:blipFill>
-          <a:blip xmlns:r="http://schemas.openxmlformats.org/officeDocument/2006/relationships" xmlns:a="http://schemas.openxmlformats.org/drawingml/2006/main" r:embed="R41bf9226936d4424"/>
+          <a:blip xmlns:r="http://schemas.openxmlformats.org/officeDocument/2006/relationships" xmlns:a="http://schemas.openxmlformats.org/drawingml/2006/main" r:embed="R8efc1f0cdfd2407c"/>
           <a:stretch xmlns:a="http://schemas.openxmlformats.org/drawingml/2006/main"/>
         </p:blipFill>
         <p:spPr>
@@ -8301,7 +8301,7 @@
     </p:spTree>
     <p:extLst>
       <p:ext uri="{BB962C8B-B14F-4D97-AF65-F5344CB8AC3E}">
-        <p14:creationId xmlns:p14="http://schemas.microsoft.com/office/powerpoint/2010/main" val="1344628528"/>
+        <p14:creationId xmlns:p14="http://schemas.microsoft.com/office/powerpoint/2010/main" val="410535360"/>
       </p:ext>
     </p:extLst>
   </p:cSld>
@@ -8325,7 +8325,7 @@
           <p:cNvPr id="2" name="">
             <a:extLst xmlns:a="http://schemas.openxmlformats.org/drawingml/2006/main">
               <a:ext uri="{FF2B5EF4-FFF2-40B4-BE49-F238E27FC236}">
-                <a16:creationId xmlns:a16="http://schemas.microsoft.com/office/drawing/2014/main" id="{D07389A8-6AB7-4A7C-B9C5-17EAFC7822FB}"/>
+                <a16:creationId xmlns:a16="http://schemas.microsoft.com/office/drawing/2014/main" id="{26ABBA3C-62D7-4159-8597-0A47DA1A3DB8}"/>
               </a:ext>
             </a:extLst>
           </p:cNvPr>
@@ -8335,7 +8335,7 @@
           <p:nvPr/>
         </p:nvPicPr>
         <p:blipFill>
-          <a:blip xmlns:r="http://schemas.openxmlformats.org/officeDocument/2006/relationships" xmlns:a="http://schemas.openxmlformats.org/drawingml/2006/main" r:embed="R127429ae689242a7"/>
+          <a:blip xmlns:r="http://schemas.openxmlformats.org/officeDocument/2006/relationships" xmlns:a="http://schemas.openxmlformats.org/drawingml/2006/main" r:embed="R393f398d157848d9"/>
           <a:stretch xmlns:a="http://schemas.openxmlformats.org/drawingml/2006/main"/>
         </p:blipFill>
         <p:spPr>
@@ -8351,7 +8351,7 @@
     </p:spTree>
     <p:extLst>
       <p:ext uri="{BB962C8B-B14F-4D97-AF65-F5344CB8AC3E}">
-        <p14:creationId xmlns:p14="http://schemas.microsoft.com/office/powerpoint/2010/main" val="1790808536"/>
+        <p14:creationId xmlns:p14="http://schemas.microsoft.com/office/powerpoint/2010/main" val="860455336"/>
       </p:ext>
     </p:extLst>
   </p:cSld>
@@ -8375,7 +8375,7 @@
           <p:cNvPr id="2" name="">
             <a:extLst xmlns:a="http://schemas.openxmlformats.org/drawingml/2006/main">
               <a:ext uri="{FF2B5EF4-FFF2-40B4-BE49-F238E27FC236}">
-                <a16:creationId xmlns:a16="http://schemas.microsoft.com/office/drawing/2014/main" id="{9A2BA1EE-529B-4518-950B-53516485779D}"/>
+                <a16:creationId xmlns:a16="http://schemas.microsoft.com/office/drawing/2014/main" id="{ABC715D0-3BB3-45D6-89C8-D7EF44804E9A}"/>
               </a:ext>
             </a:extLst>
           </p:cNvPr>
@@ -8385,7 +8385,7 @@
           <p:nvPr/>
         </p:nvPicPr>
         <p:blipFill>
-          <a:blip xmlns:r="http://schemas.openxmlformats.org/officeDocument/2006/relationships" xmlns:a="http://schemas.openxmlformats.org/drawingml/2006/main" r:embed="Rd4f5123bcade4c46"/>
+          <a:blip xmlns:r="http://schemas.openxmlformats.org/officeDocument/2006/relationships" xmlns:a="http://schemas.openxmlformats.org/drawingml/2006/main" r:embed="Rc642574b0ecc46f8"/>
           <a:stretch xmlns:a="http://schemas.openxmlformats.org/drawingml/2006/main"/>
         </p:blipFill>
         <p:spPr>
@@ -8401,7 +8401,7 @@
     </p:spTree>
     <p:extLst>
       <p:ext uri="{BB962C8B-B14F-4D97-AF65-F5344CB8AC3E}">
-        <p14:creationId xmlns:p14="http://schemas.microsoft.com/office/powerpoint/2010/main" val="855270486"/>
+        <p14:creationId xmlns:p14="http://schemas.microsoft.com/office/powerpoint/2010/main" val="769316843"/>
       </p:ext>
     </p:extLst>
   </p:cSld>
@@ -8425,7 +8425,7 @@
           <p:cNvPr id="2" name="">
             <a:extLst xmlns:a="http://schemas.openxmlformats.org/drawingml/2006/main">
               <a:ext uri="{FF2B5EF4-FFF2-40B4-BE49-F238E27FC236}">
-                <a16:creationId xmlns:a16="http://schemas.microsoft.com/office/drawing/2014/main" id="{9CF50844-81CB-4EFA-91B0-6F0C0030C081}"/>
+                <a16:creationId xmlns:a16="http://schemas.microsoft.com/office/drawing/2014/main" id="{25960B0B-FCC4-42FC-9158-34E97041FDE6}"/>
               </a:ext>
             </a:extLst>
           </p:cNvPr>
@@ -8435,7 +8435,7 @@
           <p:nvPr/>
         </p:nvPicPr>
         <p:blipFill>
-          <a:blip xmlns:r="http://schemas.openxmlformats.org/officeDocument/2006/relationships" xmlns:a="http://schemas.openxmlformats.org/drawingml/2006/main" r:embed="R3d2b31b478b54ccc"/>
+          <a:blip xmlns:r="http://schemas.openxmlformats.org/officeDocument/2006/relationships" xmlns:a="http://schemas.openxmlformats.org/drawingml/2006/main" r:embed="R833ad94768674a58"/>
           <a:stretch xmlns:a="http://schemas.openxmlformats.org/drawingml/2006/main"/>
         </p:blipFill>
         <p:spPr>
@@ -8451,7 +8451,7 @@
     </p:spTree>
     <p:extLst>
       <p:ext uri="{BB962C8B-B14F-4D97-AF65-F5344CB8AC3E}">
-        <p14:creationId xmlns:p14="http://schemas.microsoft.com/office/powerpoint/2010/main" val="1310276277"/>
+        <p14:creationId xmlns:p14="http://schemas.microsoft.com/office/powerpoint/2010/main" val="2087080316"/>
       </p:ext>
     </p:extLst>
   </p:cSld>
@@ -8475,7 +8475,7 @@
           <p:cNvPr id="2" name="">
             <a:extLst xmlns:a="http://schemas.openxmlformats.org/drawingml/2006/main">
               <a:ext uri="{FF2B5EF4-FFF2-40B4-BE49-F238E27FC236}">
-                <a16:creationId xmlns:a16="http://schemas.microsoft.com/office/drawing/2014/main" id="{56E02E7C-E08C-4546-BFF4-0A3D0F27DADE}"/>
+                <a16:creationId xmlns:a16="http://schemas.microsoft.com/office/drawing/2014/main" id="{975FAE32-5068-4585-8430-A8392BC75B77}"/>
               </a:ext>
             </a:extLst>
           </p:cNvPr>
@@ -8485,7 +8485,7 @@
           <p:nvPr/>
         </p:nvPicPr>
         <p:blipFill>
-          <a:blip xmlns:r="http://schemas.openxmlformats.org/officeDocument/2006/relationships" xmlns:a="http://schemas.openxmlformats.org/drawingml/2006/main" r:embed="R21dc0e47a4e947a0"/>
+          <a:blip xmlns:r="http://schemas.openxmlformats.org/officeDocument/2006/relationships" xmlns:a="http://schemas.openxmlformats.org/drawingml/2006/main" r:embed="R78145e7dc3ae4340"/>
           <a:stretch xmlns:a="http://schemas.openxmlformats.org/drawingml/2006/main"/>
         </p:blipFill>
         <p:spPr>
@@ -8501,7 +8501,7 @@
     </p:spTree>
     <p:extLst>
       <p:ext uri="{BB962C8B-B14F-4D97-AF65-F5344CB8AC3E}">
-        <p14:creationId xmlns:p14="http://schemas.microsoft.com/office/powerpoint/2010/main" val="148095976"/>
+        <p14:creationId xmlns:p14="http://schemas.microsoft.com/office/powerpoint/2010/main" val="410501011"/>
       </p:ext>
     </p:extLst>
   </p:cSld>
@@ -8525,7 +8525,7 @@
           <p:cNvPr id="2" name="">
             <a:extLst xmlns:a="http://schemas.openxmlformats.org/drawingml/2006/main">
               <a:ext uri="{FF2B5EF4-FFF2-40B4-BE49-F238E27FC236}">
-                <a16:creationId xmlns:a16="http://schemas.microsoft.com/office/drawing/2014/main" id="{C516CB7C-77BF-4DBA-B46A-2A2BBA273F85}"/>
+                <a16:creationId xmlns:a16="http://schemas.microsoft.com/office/drawing/2014/main" id="{59281466-56CF-4DA9-8FB8-B7AB210BD91D}"/>
               </a:ext>
             </a:extLst>
           </p:cNvPr>
@@ -8535,7 +8535,7 @@
           <p:nvPr/>
         </p:nvPicPr>
         <p:blipFill>
-          <a:blip xmlns:r="http://schemas.openxmlformats.org/officeDocument/2006/relationships" xmlns:a="http://schemas.openxmlformats.org/drawingml/2006/main" r:embed="R0c0f67a1673f4da0"/>
+          <a:blip xmlns:r="http://schemas.openxmlformats.org/officeDocument/2006/relationships" xmlns:a="http://schemas.openxmlformats.org/drawingml/2006/main" r:embed="R1a9188079e5c4232"/>
           <a:stretch xmlns:a="http://schemas.openxmlformats.org/drawingml/2006/main"/>
         </p:blipFill>
         <p:spPr>
@@ -8551,7 +8551,7 @@
     </p:spTree>
     <p:extLst>
       <p:ext uri="{BB962C8B-B14F-4D97-AF65-F5344CB8AC3E}">
-        <p14:creationId xmlns:p14="http://schemas.microsoft.com/office/powerpoint/2010/main" val="1462774307"/>
+        <p14:creationId xmlns:p14="http://schemas.microsoft.com/office/powerpoint/2010/main" val="918201764"/>
       </p:ext>
     </p:extLst>
   </p:cSld>
@@ -8575,7 +8575,7 @@
           <p:cNvPr id="2" name="">
             <a:extLst xmlns:a="http://schemas.openxmlformats.org/drawingml/2006/main">
               <a:ext uri="{FF2B5EF4-FFF2-40B4-BE49-F238E27FC236}">
-                <a16:creationId xmlns:a16="http://schemas.microsoft.com/office/drawing/2014/main" id="{84D19087-58E6-4398-9D2D-7001C67A0E94}"/>
+                <a16:creationId xmlns:a16="http://schemas.microsoft.com/office/drawing/2014/main" id="{14AD0975-0482-4EDF-9085-6004CED7C4CE}"/>
               </a:ext>
             </a:extLst>
           </p:cNvPr>
@@ -8585,7 +8585,7 @@
           <p:nvPr/>
         </p:nvPicPr>
         <p:blipFill>
-          <a:blip xmlns:r="http://schemas.openxmlformats.org/officeDocument/2006/relationships" xmlns:a="http://schemas.openxmlformats.org/drawingml/2006/main" r:embed="Rb84a8f9cb88944e7"/>
+          <a:blip xmlns:r="http://schemas.openxmlformats.org/officeDocument/2006/relationships" xmlns:a="http://schemas.openxmlformats.org/drawingml/2006/main" r:embed="R7160b6b86b4e4af5"/>
           <a:stretch xmlns:a="http://schemas.openxmlformats.org/drawingml/2006/main"/>
         </p:blipFill>
         <p:spPr>
@@ -8601,7 +8601,7 @@
     </p:spTree>
     <p:extLst>
       <p:ext uri="{BB962C8B-B14F-4D97-AF65-F5344CB8AC3E}">
-        <p14:creationId xmlns:p14="http://schemas.microsoft.com/office/powerpoint/2010/main" val="628308980"/>
+        <p14:creationId xmlns:p14="http://schemas.microsoft.com/office/powerpoint/2010/main" val="670270994"/>
       </p:ext>
     </p:extLst>
   </p:cSld>
@@ -8625,7 +8625,7 @@
           <p:cNvPr id="2" name="">
             <a:extLst xmlns:a="http://schemas.openxmlformats.org/drawingml/2006/main">
               <a:ext uri="{FF2B5EF4-FFF2-40B4-BE49-F238E27FC236}">
-                <a16:creationId xmlns:a16="http://schemas.microsoft.com/office/drawing/2014/main" id="{D03BC003-7D04-4138-B764-B6E7C41665CC}"/>
+                <a16:creationId xmlns:a16="http://schemas.microsoft.com/office/drawing/2014/main" id="{F78AA631-EC8E-42F7-B840-02E03597A28D}"/>
               </a:ext>
             </a:extLst>
           </p:cNvPr>
@@ -8635,7 +8635,7 @@
           <p:nvPr/>
         </p:nvPicPr>
         <p:blipFill>
-          <a:blip xmlns:r="http://schemas.openxmlformats.org/officeDocument/2006/relationships" xmlns:a="http://schemas.openxmlformats.org/drawingml/2006/main" r:embed="R753767e02544444b"/>
+          <a:blip xmlns:r="http://schemas.openxmlformats.org/officeDocument/2006/relationships" xmlns:a="http://schemas.openxmlformats.org/drawingml/2006/main" r:embed="R1a1cba7485a44bda"/>
           <a:stretch xmlns:a="http://schemas.openxmlformats.org/drawingml/2006/main"/>
         </p:blipFill>
         <p:spPr>
@@ -8651,7 +8651,7 @@
     </p:spTree>
     <p:extLst>
       <p:ext uri="{BB962C8B-B14F-4D97-AF65-F5344CB8AC3E}">
-        <p14:creationId xmlns:p14="http://schemas.microsoft.com/office/powerpoint/2010/main" val="276807108"/>
+        <p14:creationId xmlns:p14="http://schemas.microsoft.com/office/powerpoint/2010/main" val="808816450"/>
       </p:ext>
     </p:extLst>
   </p:cSld>

</xml_diff>

<commit_message>
Refine Lecture 3 interactions and shared lecture previews
</commit_message>
<xml_diff>
--- a/teaching/macro-applications/downloads/lecture_3.pptx
+++ b/teaching/macro-applications/downloads/lecture_3.pptx
@@ -2,44 +2,44 @@
 <file path=ppt/presentation.xml><?xml version="1.0" encoding="utf-8"?>
 <p:presentation xmlns:p="http://schemas.openxmlformats.org/presentationml/2006/main">
   <p:sldMasterIdLst>
-    <p:sldMasterId xmlns:r="http://schemas.openxmlformats.org/officeDocument/2006/relationships" id="2147483648" r:id="Ra5eb8b45cc744182"/>
+    <p:sldMasterId xmlns:r="http://schemas.openxmlformats.org/officeDocument/2006/relationships" id="2147483648" r:id="R9f083772bc9548f6"/>
   </p:sldMasterIdLst>
   <p:notesMasterIdLst>
-    <p:notesMasterId xmlns:r="http://schemas.openxmlformats.org/officeDocument/2006/relationships" r:id="R0cf7183bec1c4b93"/>
+    <p:notesMasterId xmlns:r="http://schemas.openxmlformats.org/officeDocument/2006/relationships" r:id="R9ce23a5b7a604578"/>
   </p:notesMasterIdLst>
   <p:sldIdLst>
-    <p:sldId xmlns:r="http://schemas.openxmlformats.org/officeDocument/2006/relationships" id="256" r:id="R40d4c66bb1e640c3"/>
-    <p:sldId xmlns:r="http://schemas.openxmlformats.org/officeDocument/2006/relationships" id="257" r:id="Re7f23336ab5a4d66"/>
-    <p:sldId xmlns:r="http://schemas.openxmlformats.org/officeDocument/2006/relationships" id="258" r:id="R6493c6f2ea924a4d"/>
-    <p:sldId xmlns:r="http://schemas.openxmlformats.org/officeDocument/2006/relationships" id="259" r:id="R6586104c68ad4a8a"/>
-    <p:sldId xmlns:r="http://schemas.openxmlformats.org/officeDocument/2006/relationships" id="260" r:id="R9d5c71df2c51409b"/>
-    <p:sldId xmlns:r="http://schemas.openxmlformats.org/officeDocument/2006/relationships" id="261" r:id="Rf4bff76161644312"/>
-    <p:sldId xmlns:r="http://schemas.openxmlformats.org/officeDocument/2006/relationships" id="262" r:id="Rdc10e91284a24402"/>
-    <p:sldId xmlns:r="http://schemas.openxmlformats.org/officeDocument/2006/relationships" id="263" r:id="R754cac3453054678"/>
-    <p:sldId xmlns:r="http://schemas.openxmlformats.org/officeDocument/2006/relationships" id="264" r:id="Rf81819d9045d4be1"/>
-    <p:sldId xmlns:r="http://schemas.openxmlformats.org/officeDocument/2006/relationships" id="265" r:id="R125875f7add94fff"/>
-    <p:sldId xmlns:r="http://schemas.openxmlformats.org/officeDocument/2006/relationships" id="266" r:id="R56de9e13eb734276"/>
-    <p:sldId xmlns:r="http://schemas.openxmlformats.org/officeDocument/2006/relationships" id="267" r:id="R70d6ff0bb0494258"/>
-    <p:sldId xmlns:r="http://schemas.openxmlformats.org/officeDocument/2006/relationships" id="268" r:id="R63ea99741cd24ea5"/>
-    <p:sldId xmlns:r="http://schemas.openxmlformats.org/officeDocument/2006/relationships" id="269" r:id="R0e37bf8f09bb4499"/>
-    <p:sldId xmlns:r="http://schemas.openxmlformats.org/officeDocument/2006/relationships" id="270" r:id="Rdf72c581371a45b7"/>
-    <p:sldId xmlns:r="http://schemas.openxmlformats.org/officeDocument/2006/relationships" id="271" r:id="R2439f8e531c34723"/>
-    <p:sldId xmlns:r="http://schemas.openxmlformats.org/officeDocument/2006/relationships" id="272" r:id="R146864f9a4c84537"/>
-    <p:sldId xmlns:r="http://schemas.openxmlformats.org/officeDocument/2006/relationships" id="273" r:id="Rdafac062b75042dc"/>
-    <p:sldId xmlns:r="http://schemas.openxmlformats.org/officeDocument/2006/relationships" id="274" r:id="Rfe8a51e152d6462a"/>
-    <p:sldId xmlns:r="http://schemas.openxmlformats.org/officeDocument/2006/relationships" id="275" r:id="R0e801dfb1d664237"/>
-    <p:sldId xmlns:r="http://schemas.openxmlformats.org/officeDocument/2006/relationships" id="276" r:id="R76cda800cd794baa"/>
-    <p:sldId xmlns:r="http://schemas.openxmlformats.org/officeDocument/2006/relationships" id="277" r:id="R71591d7fdc934c12"/>
-    <p:sldId xmlns:r="http://schemas.openxmlformats.org/officeDocument/2006/relationships" id="278" r:id="R4c4df11681624079"/>
-    <p:sldId xmlns:r="http://schemas.openxmlformats.org/officeDocument/2006/relationships" id="279" r:id="Rc6d5402c61204e26"/>
-    <p:sldId xmlns:r="http://schemas.openxmlformats.org/officeDocument/2006/relationships" id="280" r:id="R599c3a8eb90e4b09"/>
-    <p:sldId xmlns:r="http://schemas.openxmlformats.org/officeDocument/2006/relationships" id="281" r:id="R059b60cca18f4f12"/>
-    <p:sldId xmlns:r="http://schemas.openxmlformats.org/officeDocument/2006/relationships" id="282" r:id="R771627d6fb1f4d4b"/>
-    <p:sldId xmlns:r="http://schemas.openxmlformats.org/officeDocument/2006/relationships" id="283" r:id="Re201ef10c9a941f2"/>
-    <p:sldId xmlns:r="http://schemas.openxmlformats.org/officeDocument/2006/relationships" id="284" r:id="R29b652824d234e26"/>
-    <p:sldId xmlns:r="http://schemas.openxmlformats.org/officeDocument/2006/relationships" id="285" r:id="R1b1c1a6e12aa4936"/>
-    <p:sldId xmlns:r="http://schemas.openxmlformats.org/officeDocument/2006/relationships" id="286" r:id="R0f56ef67fc9b487f"/>
-    <p:sldId xmlns:r="http://schemas.openxmlformats.org/officeDocument/2006/relationships" id="287" r:id="Rf0860e0095594101"/>
+    <p:sldId xmlns:r="http://schemas.openxmlformats.org/officeDocument/2006/relationships" id="256" r:id="Rb070119b896340d7"/>
+    <p:sldId xmlns:r="http://schemas.openxmlformats.org/officeDocument/2006/relationships" id="257" r:id="R58230c1d16f442fc"/>
+    <p:sldId xmlns:r="http://schemas.openxmlformats.org/officeDocument/2006/relationships" id="258" r:id="R3bd151648db54d41"/>
+    <p:sldId xmlns:r="http://schemas.openxmlformats.org/officeDocument/2006/relationships" id="259" r:id="R2fbec249f9cb4ddb"/>
+    <p:sldId xmlns:r="http://schemas.openxmlformats.org/officeDocument/2006/relationships" id="260" r:id="R0d88983b7f7949af"/>
+    <p:sldId xmlns:r="http://schemas.openxmlformats.org/officeDocument/2006/relationships" id="261" r:id="R0445a7dfcb6b4cd6"/>
+    <p:sldId xmlns:r="http://schemas.openxmlformats.org/officeDocument/2006/relationships" id="262" r:id="R9fd984b7d8104f76"/>
+    <p:sldId xmlns:r="http://schemas.openxmlformats.org/officeDocument/2006/relationships" id="263" r:id="Rcc08f18c41704533"/>
+    <p:sldId xmlns:r="http://schemas.openxmlformats.org/officeDocument/2006/relationships" id="264" r:id="Rced8c8badef84998"/>
+    <p:sldId xmlns:r="http://schemas.openxmlformats.org/officeDocument/2006/relationships" id="265" r:id="R214f42fb95e347a8"/>
+    <p:sldId xmlns:r="http://schemas.openxmlformats.org/officeDocument/2006/relationships" id="266" r:id="Rbf3e9a3831f64845"/>
+    <p:sldId xmlns:r="http://schemas.openxmlformats.org/officeDocument/2006/relationships" id="267" r:id="R42c04e1ce0654103"/>
+    <p:sldId xmlns:r="http://schemas.openxmlformats.org/officeDocument/2006/relationships" id="268" r:id="Rc9619395cc3a48a5"/>
+    <p:sldId xmlns:r="http://schemas.openxmlformats.org/officeDocument/2006/relationships" id="269" r:id="R5999653797114361"/>
+    <p:sldId xmlns:r="http://schemas.openxmlformats.org/officeDocument/2006/relationships" id="270" r:id="R0c266a57b2864c25"/>
+    <p:sldId xmlns:r="http://schemas.openxmlformats.org/officeDocument/2006/relationships" id="271" r:id="Re9e17f13b2564ca6"/>
+    <p:sldId xmlns:r="http://schemas.openxmlformats.org/officeDocument/2006/relationships" id="272" r:id="Re6a54a81e3694ea9"/>
+    <p:sldId xmlns:r="http://schemas.openxmlformats.org/officeDocument/2006/relationships" id="273" r:id="R08532d6e2a574ea9"/>
+    <p:sldId xmlns:r="http://schemas.openxmlformats.org/officeDocument/2006/relationships" id="274" r:id="R7f69cf23c2ea4aa7"/>
+    <p:sldId xmlns:r="http://schemas.openxmlformats.org/officeDocument/2006/relationships" id="275" r:id="Rbe04f4da00b14295"/>
+    <p:sldId xmlns:r="http://schemas.openxmlformats.org/officeDocument/2006/relationships" id="276" r:id="R2eb53f42c4c44acf"/>
+    <p:sldId xmlns:r="http://schemas.openxmlformats.org/officeDocument/2006/relationships" id="277" r:id="Rf131b6053ead418b"/>
+    <p:sldId xmlns:r="http://schemas.openxmlformats.org/officeDocument/2006/relationships" id="278" r:id="R55e8530f71a94837"/>
+    <p:sldId xmlns:r="http://schemas.openxmlformats.org/officeDocument/2006/relationships" id="279" r:id="R9194e963b35447db"/>
+    <p:sldId xmlns:r="http://schemas.openxmlformats.org/officeDocument/2006/relationships" id="280" r:id="R5cc1b281af1c46d7"/>
+    <p:sldId xmlns:r="http://schemas.openxmlformats.org/officeDocument/2006/relationships" id="281" r:id="R1b96027dcc7248b0"/>
+    <p:sldId xmlns:r="http://schemas.openxmlformats.org/officeDocument/2006/relationships" id="282" r:id="R98576c388a064772"/>
+    <p:sldId xmlns:r="http://schemas.openxmlformats.org/officeDocument/2006/relationships" id="283" r:id="Raa4c3ef7e18a440a"/>
+    <p:sldId xmlns:r="http://schemas.openxmlformats.org/officeDocument/2006/relationships" id="284" r:id="Rd47fc8080719463d"/>
+    <p:sldId xmlns:r="http://schemas.openxmlformats.org/officeDocument/2006/relationships" id="285" r:id="R1b726e66a5c04c15"/>
+    <p:sldId xmlns:r="http://schemas.openxmlformats.org/officeDocument/2006/relationships" id="286" r:id="Reab22736c30c49fc"/>
+    <p:sldId xmlns:r="http://schemas.openxmlformats.org/officeDocument/2006/relationships" id="287" r:id="R487ff40046124866"/>
   </p:sldIdLst>
   <p:sldSz cx="12192000" cy="6858000"/>
   <p:notesSz cx="6858000" cy="9144000"/>
@@ -718,7 +718,7 @@
           </a:p>
           <a:p xmlns:a="http://schemas.openxmlformats.org/drawingml/2006/main">
             <a:r>
-              <a:t>Consequences of international trade Does more competition always raise welfare? Lower prices help consumers. What happens to producers and transport costs?</a:t>
+              <a:t>Does more competition always raise welfare? Think it through Lower prices help consumers. What happens to producers and transport costs?</a:t>
             </a:r>
           </a:p>
           <a:p xmlns:a="http://schemas.openxmlformats.org/drawingml/2006/main">
@@ -833,17 +833,17 @@
           </a:p>
           <a:p xmlns:a="http://schemas.openxmlformats.org/drawingml/2006/main">
             <a:r>
-              <a:t>Welfare effects: consumer surplus Δ C S = A + B \Delta CS=A+B A Lower price on existing consumption. B Surplus from additional consumption. Consumers buy more at a lower price: the pro-competitive effect . Blue: monopoly. Orange: after trade. Consumption rises from x M x^M to Z Z .</a:t>
-            </a:r>
-          </a:p>
-          <a:p xmlns:a="http://schemas.openxmlformats.org/drawingml/2006/main">
-            <a:r>
-              <a:t/>
-            </a:r>
-          </a:p>
-          <a:p xmlns:a="http://schemas.openxmlformats.org/drawingml/2006/main">
-            <a:r>
-              <a:t>Consumer surplus rises by A plus B as the price falls from p M to p FT. A is the saving on original consumption; B is the surplus from additional consumption.</a:t>
+              <a:t>Welfare effects: consumer surplus The price falls from p M to p FT. Consumer surplus increases by rectangle A and triangle B. A B Price / cost Quantity Demand p M p FT x x M Z c/g c × Δ C S = A + B \Delta CS=A+B A Lower price on existing consumption. B Surplus from additional consumption. Consumers buy more at a lower price: the pro-competitive effect . Blue: monopoly. Orange: after trade. Consumption rises from x M x^M to Z Z .</a:t>
+            </a:r>
+          </a:p>
+          <a:p xmlns:a="http://schemas.openxmlformats.org/drawingml/2006/main">
+            <a:r>
+              <a:t/>
+            </a:r>
+          </a:p>
+          <a:p xmlns:a="http://schemas.openxmlformats.org/drawingml/2006/main">
+            <a:r>
+              <a:t>Welfare: consumers</a:t>
             </a:r>
           </a:p>
           <a:p xmlns:a="http://schemas.openxmlformats.org/drawingml/2006/main">
@@ -948,17 +948,17 @@
           </a:p>
           <a:p xmlns:a="http://schemas.openxmlformats.org/drawingml/2006/main">
             <a:r>
-              <a:t>Welfare effects: producer surplus Δ P S = − A − C + D \Delta PS=-A-C+D −A Lower price on original monopoly sales. −C Extra transport cost on original sales now made abroad. +D Margin on new sales, after export costs. By symmetry, each firm’s total sales equal Home consumption, Z Z . Its domestic sales are x x .</a:t>
-            </a:r>
-          </a:p>
-          <a:p xmlns:a="http://schemas.openxmlformats.org/drawingml/2006/main">
-            <a:r>
-              <a:t/>
-            </a:r>
-          </a:p>
-          <a:p xmlns:a="http://schemas.openxmlformats.org/drawingml/2006/main">
-            <a:r>
-              <a:t>Producer surplus changes by minus A minus C plus D. C is extra transport cost on original monopoly sales shifted abroad; D is the margin on additional sales after export costs.</a:t>
+              <a:t>Welfare effects: producer surplus A is the loss from the lower price on original monopoly sales. C is the extra transport cost on original sales shifted abroad. D is the export margin on additional sales, already net of export costs. A C D Price / cost Quantity Demand p M p FT x x M Z c/g c × Δ P S = − A − C + D \Delta PS=-A-C+D −A Lower price on original monopoly sales. −C Extra transport cost on original sales now made abroad. +D Margin on new sales, after export costs. By symmetry, each firm’s total sales equal Home consumption, Z Z . Its domestic sales are x x .</a:t>
+            </a:r>
+          </a:p>
+          <a:p xmlns:a="http://schemas.openxmlformats.org/drawingml/2006/main">
+            <a:r>
+              <a:t/>
+            </a:r>
+          </a:p>
+          <a:p xmlns:a="http://schemas.openxmlformats.org/drawingml/2006/main">
+            <a:r>
+              <a:t>Welfare: producers</a:t>
             </a:r>
           </a:p>
           <a:p xmlns:a="http://schemas.openxmlformats.org/drawingml/2006/main">
@@ -1063,17 +1063,17 @@
           </a:p>
           <a:p xmlns:a="http://schemas.openxmlformats.org/drawingml/2006/main">
             <a:r>
-              <a:t>Welfare effects: aggregate Add the two effects Δ W = B + D − C \Delta W=B+D-C A cancels: it is a transfer from producers to consumers. Welfare rises if B + D &gt; C B+D&gt;C and falls if B + D &lt; C B+D&lt;C . What if transport costs are zero? Then C = 0 C=0 : welfare rises. Green areas are net gains; the hatched orange area is a resource cost.</a:t>
-            </a:r>
-          </a:p>
-          <a:p xmlns:a="http://schemas.openxmlformats.org/drawingml/2006/main">
-            <a:r>
-              <a:t/>
-            </a:r>
-          </a:p>
-          <a:p xmlns:a="http://schemas.openxmlformats.org/drawingml/2006/main">
-            <a:r>
-              <a:t>Area A cancels between consumers and producers. Net welfare is B plus D minus C. With no transport costs C is zero.</a:t>
+              <a:t>Welfare effects: aggregate Area A cancels between producers and consumers. The net welfare change is B plus D minus C, whose sign depends on the relative areas. B C D Price / cost Quantity Demand p M p FT x x M Z c/g c × Add the two effects Δ W = B + D − C \Delta W=B+D-C A cancels: it is a transfer from producers to consumers. Welfare rises if B + D &gt; C B+D&gt;C and falls if B + D &lt; C B+D&lt;C . What if transport costs are zero? Then C = 0 C=0 : welfare rises. Green areas are net gains; the hatched orange area is a resource cost.</a:t>
+            </a:r>
+          </a:p>
+          <a:p xmlns:a="http://schemas.openxmlformats.org/drawingml/2006/main">
+            <a:r>
+              <a:t/>
+            </a:r>
+          </a:p>
+          <a:p xmlns:a="http://schemas.openxmlformats.org/drawingml/2006/main">
+            <a:r>
+              <a:t>Welfare: total</a:t>
             </a:r>
           </a:p>
           <a:p xmlns:a="http://schemas.openxmlformats.org/drawingml/2006/main">
@@ -1178,7 +1178,7 @@
           </a:p>
           <a:p xmlns:a="http://schemas.openxmlformats.org/drawingml/2006/main">
             <a:r>
-              <a:t>Market size and industrial restructuring How does a larger market change the industry? More firms compete at first. After exit, the surviving firms are larger. Why might firms exit? The initial price falls below average cost, so firms make losses. Can welfare rise even when firms exit? Yes. In this free-entry model, profits return to zero while consumers pay less.</a:t>
+              <a:t>Can a larger market mean fewer firms? Reveal the mechanism Competition: more firms initially compete in each market, pushing the price down. Exit: losses force some firms out. The surviving firms become larger. Welfare: profits return to zero while consumers pay less.</a:t>
             </a:r>
           </a:p>
           <a:p xmlns:a="http://schemas.openxmlformats.org/drawingml/2006/main">
@@ -1293,7 +1293,7 @@
           </a:p>
           <a:p xmlns:a="http://schemas.openxmlformats.org/drawingml/2006/main">
             <a:r>
-              <a:t>Allowing entry and exit The number of firms can now change. Earlier: a fixed number One firm in each country. Now: free entry Entry and exit determine how many firms remain. Start with a closed economy, then open the markets. Brander and Krugman (1983).</a:t>
+              <a:t>From two firms to many firms Each country can now have many firms . Competition Each firm chooses its output, taking its rivals’ output as given. Entry and exit Firms enter when there are profits and exit when there are losses. In the long run, profits are zero .</a:t>
             </a:r>
           </a:p>
           <a:p xmlns:a="http://schemas.openxmlformats.org/drawingml/2006/main">
@@ -2213,37 +2213,37 @@
           </a:p>
           <a:p xmlns:a="http://schemas.openxmlformats.org/drawingml/2006/main">
             <a:r>
-              <a:t>Empirical evidence Price-cost margins for French industry, 1986–2004 . Source: Baldwin and Wyplosz (2012).</a:t>
-            </a:r>
-          </a:p>
-          <a:p xmlns:a="http://schemas.openxmlformats.org/drawingml/2006/main">
-            <a:r>
-              <a:t/>
-            </a:r>
-          </a:p>
-          <a:p xmlns:a="http://schemas.openxmlformats.org/drawingml/2006/main">
-            <a:r>
-              <a:t>Line chart of French industrial price-cost margins, 1986 to 2004. Margins fluctuate but are lower at the end of the period than at the beginning. Source: Baldwin and Wyplosz, 2012.</a:t>
-            </a:r>
-          </a:p>
-          <a:p xmlns:a="http://schemas.openxmlformats.org/drawingml/2006/main">
-            <a:r>
-              <a:t/>
-            </a:r>
-          </a:p>
-          <a:p xmlns:a="http://schemas.openxmlformats.org/drawingml/2006/main">
-            <a:r>
-              <a:t/>
-            </a:r>
-          </a:p>
-          <a:p xmlns:a="http://schemas.openxmlformats.org/drawingml/2006/main">
-            <a:r>
-              <a:t/>
-            </a:r>
-          </a:p>
-          <a:p xmlns:a="http://schemas.openxmlformats.org/drawingml/2006/main">
-            <a:r>
-              <a:t/>
+              <a:t>What does the evidence show? The model More competition pushes mark-ups down. The evidence Estimated mark-ups rose by about 7% over 2000–2019. Does that contradict the model? A time trend does not isolate integration. Technology, costs and barriers to entry also change. European Commission (2024), Figure 28, p. 61 , based on OECD (Calligaris et al., 2024). Mark-up: price / marginal cost (our model: price − marginal cost). Approximate endpoints.</a:t>
+            </a:r>
+          </a:p>
+          <a:p xmlns:a="http://schemas.openxmlformats.org/drawingml/2006/main">
+            <a:r>
+              <a:t/>
+            </a:r>
+          </a:p>
+          <a:p xmlns:a="http://schemas.openxmlformats.org/drawingml/2006/main">
+            <a:r>
+              <a:t>Endpoint comparison: the average estimated firm-level mark-up rose by about 7 percent from 2000 to 2019 in a sample of 23 European countries. Indexed to 100 in 2000, the reported approximate endpoint is 107. This is a time trend, not a causal estimate of market integration.</a:t>
+            </a:r>
+          </a:p>
+          <a:p xmlns:a="http://schemas.openxmlformats.org/drawingml/2006/main">
+            <a:r>
+              <a:t/>
+            </a:r>
+          </a:p>
+          <a:p xmlns:a="http://schemas.openxmlformats.org/drawingml/2006/main">
+            <a:r>
+              <a:t/>
+            </a:r>
+          </a:p>
+          <a:p xmlns:a="http://schemas.openxmlformats.org/drawingml/2006/main">
+            <a:r>
+              <a:t/>
+            </a:r>
+          </a:p>
+          <a:p xmlns:a="http://schemas.openxmlformats.org/drawingml/2006/main">
+            <a:r>
+              <a:t>https://competition-policy.ec.europa.eu/system/files/2024-06/KD0924494enn_Protecting_competition_in_a_changing_world_staff_report_2024.pdf#page=69</a:t>
             </a:r>
           </a:p>
         </p:txBody>
@@ -2558,7 +2558,7 @@
           </a:p>
           <a:p xmlns:a="http://schemas.openxmlformats.org/drawingml/2006/main">
             <a:r>
-              <a:t>Next lecture Migration What changes when workers, as well as goods, can cross borders? Wages and employment · Who gains and loses · Trade and labour mobility</a:t>
+              <a:t>Next lecture Migration What changes when workers, as well as goods, can cross borders? Preparation: Revise labour supply, labour demand and marginal productivity.</a:t>
             </a:r>
           </a:p>
           <a:p xmlns:a="http://schemas.openxmlformats.org/drawingml/2006/main">
@@ -2673,7 +2673,7 @@
           </a:p>
           <a:p xmlns:a="http://schemas.openxmlformats.org/drawingml/2006/main">
             <a:r>
-              <a:t>References Essential reading Baldwin and Wyplosz, The Economics of European Integration , Chapter 6 (any edition) . Brander J., and Krugman P. (1983), A ‘reciprocal dumping’ model of international trade, Journal of International Economics, 15, 313-321. Further reading See the ECON2271 Talis reading list , also available through Blackboard.</a:t>
+              <a:t>References Essential reading Baldwin and Wyplosz, The Economics of European Integration , “Scale economies and competition” (Chapter 6 in the seventh edition) . Brander J., and Krugman P. (1983), A ‘reciprocal dumping’ model of international trade, Journal of International Economics, 15, 313-321. Other editions are fine; find the chapter by its title. Further reading See the ECON2271 Talis reading list , also available through Blackboard.</a:t>
             </a:r>
           </a:p>
           <a:p xmlns:a="http://schemas.openxmlformats.org/drawingml/2006/main">
@@ -3593,17 +3593,17 @@
           </a:p>
           <a:p xmlns:a="http://schemas.openxmlformats.org/drawingml/2006/main">
             <a:r>
-              <a:t>Two monopolistic markets One monopolist in each country max x ( p − c ) x − F \max_x\;(p-c)x-F p = a − b x p=a-bx Set MR = MC x M = a − c 2 b , p M = a + c 2 x^M=\frac{a-c}{2b},\quad p^M=\frac{a+c}{2} π M = ( a − c ) 2 4 b − F \pi^M=\frac{(a-c)^2}{4b}-F F F is the fixed cost. The same diagram applies to Home and Foreign before trade.</a:t>
-            </a:r>
-          </a:p>
-          <a:p xmlns:a="http://schemas.openxmlformats.org/drawingml/2006/main">
-            <a:r>
-              <a:t/>
-            </a:r>
-          </a:p>
-          <a:p xmlns:a="http://schemas.openxmlformats.org/drawingml/2006/main">
-            <a:r>
-              <a:t>Each country has a monopolist. Marginal revenue equals marginal cost at x M; demand determines p M. The shaded rectangle is profit after fixed costs.</a:t>
+              <a:t>Two monopolistic markets One monopolist per country max x ( p − c ) x − F \max_x\;(p-c)x-F p = a − b x p=a-bx Set MR = MC Output x M = a − c 2 b x^M=\dfrac{a-c}{2b} Price p M = a + c 2 p^M=\dfrac{a+c}{2} Profit π M = ( a − c ) 2 4 b − F \pi^M=\dfrac{(a-c)^2}{4b}-F F F is the fixed cost. The same diagram applies to Home and Foreign before trade.</a:t>
+            </a:r>
+          </a:p>
+          <a:p xmlns:a="http://schemas.openxmlformats.org/drawingml/2006/main">
+            <a:r>
+              <a:t/>
+            </a:r>
+          </a:p>
+          <a:p xmlns:a="http://schemas.openxmlformats.org/drawingml/2006/main">
+            <a:r>
+              <a:t>Each country has one monopolist. MR equals MC at x M; demand determines p M. The shaded rectangle is profit after fixed costs.</a:t>
             </a:r>
           </a:p>
           <a:p xmlns:a="http://schemas.openxmlformats.org/drawingml/2006/main">
@@ -4053,7 +4053,7 @@
           </a:p>
           <a:p xmlns:a="http://schemas.openxmlformats.org/drawingml/2006/main">
             <a:r>
-              <a:t>Equilibrium in the Home market Reaction functions Rewrite (1) and (3): x = a − b y − c 2 b x=\frac{a-by-c}{2b} y = a − b x − c / g 2 b y=\frac{a-bx-c/g}{2b} With transport costs, x &gt; y x&gt;y : each firm has a larger share at home. By symmetry: x * = y x^*=y and y * = x y^*=x . Each reaction function gives a firm’s best response to the other firm’s sales.</a:t>
+              <a:t>Equilibrium in the Home market Reaction functions The firms’ best responses, from (1) and (3): x = a − b y − c 2 b x=\frac{a-by-c}{2b} y = a − b x − c / g 2 b y=\frac{a-bx-c/g}{2b} With transport costs, x &gt; y x&gt;y : each firm has a larger share at home. By symmetry: x * = y x^*=y and y * = x y^*=x . Each reaction function gives a firm’s best response to the other firm’s sales.</a:t>
             </a:r>
           </a:p>
           <a:p xmlns:a="http://schemas.openxmlformats.org/drawingml/2006/main">
@@ -4130,7 +4130,7 @@
           <p:cNvPr id="3" name="Title">
             <a:extLst xmlns:a="http://schemas.openxmlformats.org/drawingml/2006/main">
               <a:ext uri="{FF2B5EF4-FFF2-40B4-BE49-F238E27FC236}">
-                <a16:creationId xmlns:a16="http://schemas.microsoft.com/office/drawing/2014/main" id="{D6493360-2D5D-4750-AADB-AAF63D1BD169}"/>
+                <a16:creationId xmlns:a16="http://schemas.microsoft.com/office/drawing/2014/main" id="{5F142D9A-66BB-4227-A493-B43D3778A3DA}"/>
               </a:ext>
             </a:extLst>
           </p:cNvPr>
@@ -4359,7 +4359,7 @@
           <p:cNvPr id="2" name="Subtitle">
             <a:extLst xmlns:a="http://schemas.openxmlformats.org/drawingml/2006/main">
               <a:ext uri="{FF2B5EF4-FFF2-40B4-BE49-F238E27FC236}">
-                <a16:creationId xmlns:a16="http://schemas.microsoft.com/office/drawing/2014/main" id="{A1377BBE-2CA8-4863-B962-EB5FDF6A21FD}"/>
+                <a16:creationId xmlns:a16="http://schemas.microsoft.com/office/drawing/2014/main" id="{D82E2AFA-FCE3-4E84-89AF-A6FEE1675130}"/>
               </a:ext>
             </a:extLst>
           </p:cNvPr>
@@ -4605,7 +4605,7 @@
           <p:cNvPr id="2" name="Section title">
             <a:extLst xmlns:a="http://schemas.openxmlformats.org/drawingml/2006/main">
               <a:ext uri="{FF2B5EF4-FFF2-40B4-BE49-F238E27FC236}">
-                <a16:creationId xmlns:a16="http://schemas.microsoft.com/office/drawing/2014/main" id="{1982C5CA-6E2C-4707-8367-36C45F48FFC5}"/>
+                <a16:creationId xmlns:a16="http://schemas.microsoft.com/office/drawing/2014/main" id="{50BBCB3F-6AE3-46CC-9F81-8A61F0E86B53}"/>
               </a:ext>
             </a:extLst>
           </p:cNvPr>
@@ -4851,7 +4851,7 @@
           <p:cNvPr id="3" name="Title">
             <a:extLst xmlns:a="http://schemas.openxmlformats.org/drawingml/2006/main">
               <a:ext uri="{FF2B5EF4-FFF2-40B4-BE49-F238E27FC236}">
-                <a16:creationId xmlns:a16="http://schemas.microsoft.com/office/drawing/2014/main" id="{9D7ADCD7-203D-4B89-AA54-AAF5706CA5CD}"/>
+                <a16:creationId xmlns:a16="http://schemas.microsoft.com/office/drawing/2014/main" id="{87008ADA-34B1-4BD7-9E77-9A4F110AD6D5}"/>
               </a:ext>
             </a:extLst>
           </p:cNvPr>
@@ -5080,7 +5080,7 @@
           <p:cNvPr id="2" name="Body">
             <a:extLst xmlns:a="http://schemas.openxmlformats.org/drawingml/2006/main">
               <a:ext uri="{FF2B5EF4-FFF2-40B4-BE49-F238E27FC236}">
-                <a16:creationId xmlns:a16="http://schemas.microsoft.com/office/drawing/2014/main" id="{DE04BED0-DD49-4A84-9935-DD44DB4BDD59}"/>
+                <a16:creationId xmlns:a16="http://schemas.microsoft.com/office/drawing/2014/main" id="{F77FEB46-D565-4441-834E-D9C7FA06261F}"/>
               </a:ext>
             </a:extLst>
           </p:cNvPr>
@@ -5326,7 +5326,7 @@
           <p:cNvPr id="4" name="Title">
             <a:extLst xmlns:a="http://schemas.openxmlformats.org/drawingml/2006/main">
               <a:ext uri="{FF2B5EF4-FFF2-40B4-BE49-F238E27FC236}">
-                <a16:creationId xmlns:a16="http://schemas.microsoft.com/office/drawing/2014/main" id="{0A9F45B0-B0F8-47E4-85F1-40A9D66C066F}"/>
+                <a16:creationId xmlns:a16="http://schemas.microsoft.com/office/drawing/2014/main" id="{69664585-A10A-4AA8-A611-656B844AB980}"/>
               </a:ext>
             </a:extLst>
           </p:cNvPr>
@@ -5555,7 +5555,7 @@
           <p:cNvPr id="2" name="Left column">
             <a:extLst xmlns:a="http://schemas.openxmlformats.org/drawingml/2006/main">
               <a:ext uri="{FF2B5EF4-FFF2-40B4-BE49-F238E27FC236}">
-                <a16:creationId xmlns:a16="http://schemas.microsoft.com/office/drawing/2014/main" id="{C4C9811F-6721-48A0-934C-25C2FC77EDF4}"/>
+                <a16:creationId xmlns:a16="http://schemas.microsoft.com/office/drawing/2014/main" id="{3D2A724D-5384-4B55-9B21-59CAAF3C893E}"/>
               </a:ext>
             </a:extLst>
           </p:cNvPr>
@@ -5784,7 +5784,7 @@
           <p:cNvPr id="3" name="Right column">
             <a:extLst xmlns:a="http://schemas.openxmlformats.org/drawingml/2006/main">
               <a:ext uri="{FF2B5EF4-FFF2-40B4-BE49-F238E27FC236}">
-                <a16:creationId xmlns:a16="http://schemas.microsoft.com/office/drawing/2014/main" id="{7D9CC9D6-FA61-439B-B4DB-C89773A5D700}"/>
+                <a16:creationId xmlns:a16="http://schemas.microsoft.com/office/drawing/2014/main" id="{7E4E150A-6992-4F3C-9C4E-9F7DD1BB11A7}"/>
               </a:ext>
             </a:extLst>
           </p:cNvPr>
@@ -6030,7 +6030,7 @@
           <p:cNvPr id="3" name="Title">
             <a:extLst xmlns:a="http://schemas.openxmlformats.org/drawingml/2006/main">
               <a:ext uri="{FF2B5EF4-FFF2-40B4-BE49-F238E27FC236}">
-                <a16:creationId xmlns:a16="http://schemas.microsoft.com/office/drawing/2014/main" id="{3FF72CE8-8762-4469-9535-584F5B8F52C0}"/>
+                <a16:creationId xmlns:a16="http://schemas.microsoft.com/office/drawing/2014/main" id="{AB25D953-E8B9-4B48-A6AB-5B8A1937463E}"/>
               </a:ext>
             </a:extLst>
           </p:cNvPr>
@@ -6259,7 +6259,7 @@
           <p:cNvPr id="2" name="Left column">
             <a:extLst xmlns:a="http://schemas.openxmlformats.org/drawingml/2006/main">
               <a:ext uri="{FF2B5EF4-FFF2-40B4-BE49-F238E27FC236}">
-                <a16:creationId xmlns:a16="http://schemas.microsoft.com/office/drawing/2014/main" id="{9BD9BF2D-328E-4E8A-83D6-56DC70FD6DAD}"/>
+                <a16:creationId xmlns:a16="http://schemas.microsoft.com/office/drawing/2014/main" id="{9583988B-FBC4-454F-865C-C29689ACAAB4}"/>
               </a:ext>
             </a:extLst>
           </p:cNvPr>
@@ -6526,12 +6526,12 @@
   </p:cSld>
   <p:clrMap bg1="lt1" tx1="dk1" bg2="lt2" tx2="dk2" accent1="accent1" accent2="accent2" accent3="accent3" accent4="accent4" accent5="accent5" accent6="accent6" hlink="hlink" folHlink="folHlink"/>
   <p:sldLayoutIdLst>
-    <p:sldLayoutId xmlns:r="http://schemas.openxmlformats.org/officeDocument/2006/relationships" id="2147483649" r:id="R9be0c7fb28fd4e4b"/>
-    <p:sldLayoutId xmlns:r="http://schemas.openxmlformats.org/officeDocument/2006/relationships" id="2147483650" r:id="R3760e0dcf3a14ff1"/>
-    <p:sldLayoutId xmlns:r="http://schemas.openxmlformats.org/officeDocument/2006/relationships" id="2147483651" r:id="R98d631802cf24050"/>
-    <p:sldLayoutId xmlns:r="http://schemas.openxmlformats.org/officeDocument/2006/relationships" id="2147483652" r:id="Rff18c465b6e94a78"/>
-    <p:sldLayoutId xmlns:r="http://schemas.openxmlformats.org/officeDocument/2006/relationships" id="2147483653" r:id="R0aae4352d6ed400e"/>
-    <p:sldLayoutId xmlns:r="http://schemas.openxmlformats.org/officeDocument/2006/relationships" id="2147483654" r:id="R1798f378e4f24b54"/>
+    <p:sldLayoutId xmlns:r="http://schemas.openxmlformats.org/officeDocument/2006/relationships" id="2147483649" r:id="Rbce3d129a7fc446b"/>
+    <p:sldLayoutId xmlns:r="http://schemas.openxmlformats.org/officeDocument/2006/relationships" id="2147483650" r:id="R0f48a8b012ee4577"/>
+    <p:sldLayoutId xmlns:r="http://schemas.openxmlformats.org/officeDocument/2006/relationships" id="2147483651" r:id="Rad5a3c2d262e4dc4"/>
+    <p:sldLayoutId xmlns:r="http://schemas.openxmlformats.org/officeDocument/2006/relationships" id="2147483652" r:id="R0c908c4637c042c3"/>
+    <p:sldLayoutId xmlns:r="http://schemas.openxmlformats.org/officeDocument/2006/relationships" id="2147483653" r:id="R4f913ff71ff74a14"/>
+    <p:sldLayoutId xmlns:r="http://schemas.openxmlformats.org/officeDocument/2006/relationships" id="2147483654" r:id="R8442df14134a4a46"/>
   </p:sldLayoutIdLst>
   <p:txStyles>
     <p:titleStyle>
@@ -7075,7 +7075,7 @@
           <p:cNvPr id="2" name="">
             <a:extLst xmlns:a="http://schemas.openxmlformats.org/drawingml/2006/main">
               <a:ext uri="{FF2B5EF4-FFF2-40B4-BE49-F238E27FC236}">
-                <a16:creationId xmlns:a16="http://schemas.microsoft.com/office/drawing/2014/main" id="{E56599A0-1FDF-40FD-8345-FC9B976E334B}"/>
+                <a16:creationId xmlns:a16="http://schemas.microsoft.com/office/drawing/2014/main" id="{65D20A7E-2198-45B1-A6C8-46BD2ACCFCFC}"/>
               </a:ext>
             </a:extLst>
           </p:cNvPr>
@@ -7085,7 +7085,7 @@
           <p:nvPr/>
         </p:nvPicPr>
         <p:blipFill>
-          <a:blip xmlns:r="http://schemas.openxmlformats.org/officeDocument/2006/relationships" xmlns:a="http://schemas.openxmlformats.org/drawingml/2006/main" r:embed="R54f0812d6de7468a"/>
+          <a:blip xmlns:r="http://schemas.openxmlformats.org/officeDocument/2006/relationships" xmlns:a="http://schemas.openxmlformats.org/drawingml/2006/main" r:embed="R73725c2d1d7648f8"/>
           <a:stretch xmlns:a="http://schemas.openxmlformats.org/drawingml/2006/main"/>
         </p:blipFill>
         <p:spPr>
@@ -7101,7 +7101,7 @@
     </p:spTree>
     <p:extLst>
       <p:ext uri="{BB962C8B-B14F-4D97-AF65-F5344CB8AC3E}">
-        <p14:creationId xmlns:p14="http://schemas.microsoft.com/office/powerpoint/2010/main" val="436615682"/>
+        <p14:creationId xmlns:p14="http://schemas.microsoft.com/office/powerpoint/2010/main" val="1099671555"/>
       </p:ext>
     </p:extLst>
   </p:cSld>
@@ -7125,7 +7125,7 @@
           <p:cNvPr id="2" name="">
             <a:extLst xmlns:a="http://schemas.openxmlformats.org/drawingml/2006/main">
               <a:ext uri="{FF2B5EF4-FFF2-40B4-BE49-F238E27FC236}">
-                <a16:creationId xmlns:a16="http://schemas.microsoft.com/office/drawing/2014/main" id="{79153719-CFAC-4E3F-8F27-21B1C375C22A}"/>
+                <a16:creationId xmlns:a16="http://schemas.microsoft.com/office/drawing/2014/main" id="{744BE571-78CC-4394-AEB1-ED378FCE487C}"/>
               </a:ext>
             </a:extLst>
           </p:cNvPr>
@@ -7135,7 +7135,7 @@
           <p:nvPr/>
         </p:nvPicPr>
         <p:blipFill>
-          <a:blip xmlns:r="http://schemas.openxmlformats.org/officeDocument/2006/relationships" xmlns:a="http://schemas.openxmlformats.org/drawingml/2006/main" r:embed="R42f5c17b53894515"/>
+          <a:blip xmlns:r="http://schemas.openxmlformats.org/officeDocument/2006/relationships" xmlns:a="http://schemas.openxmlformats.org/drawingml/2006/main" r:embed="R1e9ce46e260b47d6"/>
           <a:stretch xmlns:a="http://schemas.openxmlformats.org/drawingml/2006/main"/>
         </p:blipFill>
         <p:spPr>
@@ -7151,7 +7151,7 @@
     </p:spTree>
     <p:extLst>
       <p:ext uri="{BB962C8B-B14F-4D97-AF65-F5344CB8AC3E}">
-        <p14:creationId xmlns:p14="http://schemas.microsoft.com/office/powerpoint/2010/main" val="1186395042"/>
+        <p14:creationId xmlns:p14="http://schemas.microsoft.com/office/powerpoint/2010/main" val="604642099"/>
       </p:ext>
     </p:extLst>
   </p:cSld>
@@ -7175,7 +7175,7 @@
           <p:cNvPr id="2" name="">
             <a:extLst xmlns:a="http://schemas.openxmlformats.org/drawingml/2006/main">
               <a:ext uri="{FF2B5EF4-FFF2-40B4-BE49-F238E27FC236}">
-                <a16:creationId xmlns:a16="http://schemas.microsoft.com/office/drawing/2014/main" id="{2C3B90ED-33C8-4C31-A688-E9C9DE82451D}"/>
+                <a16:creationId xmlns:a16="http://schemas.microsoft.com/office/drawing/2014/main" id="{84FD0DFC-0FDA-4488-96EF-8D6B0CE8145D}"/>
               </a:ext>
             </a:extLst>
           </p:cNvPr>
@@ -7185,7 +7185,7 @@
           <p:nvPr/>
         </p:nvPicPr>
         <p:blipFill>
-          <a:blip xmlns:r="http://schemas.openxmlformats.org/officeDocument/2006/relationships" xmlns:a="http://schemas.openxmlformats.org/drawingml/2006/main" r:embed="R695b3549edb14e4c"/>
+          <a:blip xmlns:r="http://schemas.openxmlformats.org/officeDocument/2006/relationships" xmlns:a="http://schemas.openxmlformats.org/drawingml/2006/main" r:embed="Re9f73e15519049ef"/>
           <a:stretch xmlns:a="http://schemas.openxmlformats.org/drawingml/2006/main"/>
         </p:blipFill>
         <p:spPr>
@@ -7201,7 +7201,7 @@
     </p:spTree>
     <p:extLst>
       <p:ext uri="{BB962C8B-B14F-4D97-AF65-F5344CB8AC3E}">
-        <p14:creationId xmlns:p14="http://schemas.microsoft.com/office/powerpoint/2010/main" val="882294915"/>
+        <p14:creationId xmlns:p14="http://schemas.microsoft.com/office/powerpoint/2010/main" val="1931094515"/>
       </p:ext>
     </p:extLst>
   </p:cSld>
@@ -7225,7 +7225,7 @@
           <p:cNvPr id="2" name="">
             <a:extLst xmlns:a="http://schemas.openxmlformats.org/drawingml/2006/main">
               <a:ext uri="{FF2B5EF4-FFF2-40B4-BE49-F238E27FC236}">
-                <a16:creationId xmlns:a16="http://schemas.microsoft.com/office/drawing/2014/main" id="{09B4E229-629C-4556-957F-3AEDB9B7C875}"/>
+                <a16:creationId xmlns:a16="http://schemas.microsoft.com/office/drawing/2014/main" id="{4434BE99-72E5-464E-8BC8-FA3A46993AF7}"/>
               </a:ext>
             </a:extLst>
           </p:cNvPr>
@@ -7235,7 +7235,7 @@
           <p:nvPr/>
         </p:nvPicPr>
         <p:blipFill>
-          <a:blip xmlns:r="http://schemas.openxmlformats.org/officeDocument/2006/relationships" xmlns:a="http://schemas.openxmlformats.org/drawingml/2006/main" r:embed="R4ba00444db524a6c"/>
+          <a:blip xmlns:r="http://schemas.openxmlformats.org/officeDocument/2006/relationships" xmlns:a="http://schemas.openxmlformats.org/drawingml/2006/main" r:embed="Ra59730a25a4b4caf"/>
           <a:stretch xmlns:a="http://schemas.openxmlformats.org/drawingml/2006/main"/>
         </p:blipFill>
         <p:spPr>
@@ -7251,7 +7251,7 @@
     </p:spTree>
     <p:extLst>
       <p:ext uri="{BB962C8B-B14F-4D97-AF65-F5344CB8AC3E}">
-        <p14:creationId xmlns:p14="http://schemas.microsoft.com/office/powerpoint/2010/main" val="242584312"/>
+        <p14:creationId xmlns:p14="http://schemas.microsoft.com/office/powerpoint/2010/main" val="598244585"/>
       </p:ext>
     </p:extLst>
   </p:cSld>
@@ -7275,7 +7275,7 @@
           <p:cNvPr id="2" name="">
             <a:extLst xmlns:a="http://schemas.openxmlformats.org/drawingml/2006/main">
               <a:ext uri="{FF2B5EF4-FFF2-40B4-BE49-F238E27FC236}">
-                <a16:creationId xmlns:a16="http://schemas.microsoft.com/office/drawing/2014/main" id="{FF589A52-F175-48CF-8D47-99AD63EE35F3}"/>
+                <a16:creationId xmlns:a16="http://schemas.microsoft.com/office/drawing/2014/main" id="{970E9976-D175-4EBC-A2DE-0E6D892178B7}"/>
               </a:ext>
             </a:extLst>
           </p:cNvPr>
@@ -7285,7 +7285,7 @@
           <p:nvPr/>
         </p:nvPicPr>
         <p:blipFill>
-          <a:blip xmlns:r="http://schemas.openxmlformats.org/officeDocument/2006/relationships" xmlns:a="http://schemas.openxmlformats.org/drawingml/2006/main" r:embed="R9ee420aa9f854c9e"/>
+          <a:blip xmlns:r="http://schemas.openxmlformats.org/officeDocument/2006/relationships" xmlns:a="http://schemas.openxmlformats.org/drawingml/2006/main" r:embed="R6b667ab1003f4a91"/>
           <a:stretch xmlns:a="http://schemas.openxmlformats.org/drawingml/2006/main"/>
         </p:blipFill>
         <p:spPr>
@@ -7301,7 +7301,7 @@
     </p:spTree>
     <p:extLst>
       <p:ext uri="{BB962C8B-B14F-4D97-AF65-F5344CB8AC3E}">
-        <p14:creationId xmlns:p14="http://schemas.microsoft.com/office/powerpoint/2010/main" val="1062306314"/>
+        <p14:creationId xmlns:p14="http://schemas.microsoft.com/office/powerpoint/2010/main" val="1941823045"/>
       </p:ext>
     </p:extLst>
   </p:cSld>
@@ -7325,7 +7325,7 @@
           <p:cNvPr id="2" name="">
             <a:extLst xmlns:a="http://schemas.openxmlformats.org/drawingml/2006/main">
               <a:ext uri="{FF2B5EF4-FFF2-40B4-BE49-F238E27FC236}">
-                <a16:creationId xmlns:a16="http://schemas.microsoft.com/office/drawing/2014/main" id="{467E4D84-8608-44E3-AAC2-473195ECC554}"/>
+                <a16:creationId xmlns:a16="http://schemas.microsoft.com/office/drawing/2014/main" id="{A8652EB5-CFFF-4937-9C3C-5CAE01179D61}"/>
               </a:ext>
             </a:extLst>
           </p:cNvPr>
@@ -7335,7 +7335,7 @@
           <p:nvPr/>
         </p:nvPicPr>
         <p:blipFill>
-          <a:blip xmlns:r="http://schemas.openxmlformats.org/officeDocument/2006/relationships" xmlns:a="http://schemas.openxmlformats.org/drawingml/2006/main" r:embed="R098979e448824895"/>
+          <a:blip xmlns:r="http://schemas.openxmlformats.org/officeDocument/2006/relationships" xmlns:a="http://schemas.openxmlformats.org/drawingml/2006/main" r:embed="R8f801129aed449a9"/>
           <a:stretch xmlns:a="http://schemas.openxmlformats.org/drawingml/2006/main"/>
         </p:blipFill>
         <p:spPr>
@@ -7351,7 +7351,7 @@
     </p:spTree>
     <p:extLst>
       <p:ext uri="{BB962C8B-B14F-4D97-AF65-F5344CB8AC3E}">
-        <p14:creationId xmlns:p14="http://schemas.microsoft.com/office/powerpoint/2010/main" val="126725741"/>
+        <p14:creationId xmlns:p14="http://schemas.microsoft.com/office/powerpoint/2010/main" val="406051216"/>
       </p:ext>
     </p:extLst>
   </p:cSld>
@@ -7375,7 +7375,7 @@
           <p:cNvPr id="2" name="">
             <a:extLst xmlns:a="http://schemas.openxmlformats.org/drawingml/2006/main">
               <a:ext uri="{FF2B5EF4-FFF2-40B4-BE49-F238E27FC236}">
-                <a16:creationId xmlns:a16="http://schemas.microsoft.com/office/drawing/2014/main" id="{3B0E34EC-559C-4DB0-A4FF-9E20238FE6CA}"/>
+                <a16:creationId xmlns:a16="http://schemas.microsoft.com/office/drawing/2014/main" id="{6A2B926D-6B44-40F0-9EBF-941D6FC7EE34}"/>
               </a:ext>
             </a:extLst>
           </p:cNvPr>
@@ -7385,7 +7385,7 @@
           <p:nvPr/>
         </p:nvPicPr>
         <p:blipFill>
-          <a:blip xmlns:r="http://schemas.openxmlformats.org/officeDocument/2006/relationships" xmlns:a="http://schemas.openxmlformats.org/drawingml/2006/main" r:embed="R6fe78c1013f54ba1"/>
+          <a:blip xmlns:r="http://schemas.openxmlformats.org/officeDocument/2006/relationships" xmlns:a="http://schemas.openxmlformats.org/drawingml/2006/main" r:embed="R37e9c0a4dc9a4b8b"/>
           <a:stretch xmlns:a="http://schemas.openxmlformats.org/drawingml/2006/main"/>
         </p:blipFill>
         <p:spPr>
@@ -7401,7 +7401,7 @@
     </p:spTree>
     <p:extLst>
       <p:ext uri="{BB962C8B-B14F-4D97-AF65-F5344CB8AC3E}">
-        <p14:creationId xmlns:p14="http://schemas.microsoft.com/office/powerpoint/2010/main" val="1611762864"/>
+        <p14:creationId xmlns:p14="http://schemas.microsoft.com/office/powerpoint/2010/main" val="63184080"/>
       </p:ext>
     </p:extLst>
   </p:cSld>
@@ -7425,7 +7425,7 @@
           <p:cNvPr id="2" name="">
             <a:extLst xmlns:a="http://schemas.openxmlformats.org/drawingml/2006/main">
               <a:ext uri="{FF2B5EF4-FFF2-40B4-BE49-F238E27FC236}">
-                <a16:creationId xmlns:a16="http://schemas.microsoft.com/office/drawing/2014/main" id="{5C0940DE-63EC-41B0-8DCF-047F4F877750}"/>
+                <a16:creationId xmlns:a16="http://schemas.microsoft.com/office/drawing/2014/main" id="{4CD3487F-5D68-4A4B-8A59-83543FAA33AA}"/>
               </a:ext>
             </a:extLst>
           </p:cNvPr>
@@ -7435,7 +7435,7 @@
           <p:nvPr/>
         </p:nvPicPr>
         <p:blipFill>
-          <a:blip xmlns:r="http://schemas.openxmlformats.org/officeDocument/2006/relationships" xmlns:a="http://schemas.openxmlformats.org/drawingml/2006/main" r:embed="Ra43442ac7a1d436a"/>
+          <a:blip xmlns:r="http://schemas.openxmlformats.org/officeDocument/2006/relationships" xmlns:a="http://schemas.openxmlformats.org/drawingml/2006/main" r:embed="R33c03a13c1194b5c"/>
           <a:stretch xmlns:a="http://schemas.openxmlformats.org/drawingml/2006/main"/>
         </p:blipFill>
         <p:spPr>
@@ -7451,7 +7451,7 @@
     </p:spTree>
     <p:extLst>
       <p:ext uri="{BB962C8B-B14F-4D97-AF65-F5344CB8AC3E}">
-        <p14:creationId xmlns:p14="http://schemas.microsoft.com/office/powerpoint/2010/main" val="1946253017"/>
+        <p14:creationId xmlns:p14="http://schemas.microsoft.com/office/powerpoint/2010/main" val="96589884"/>
       </p:ext>
     </p:extLst>
   </p:cSld>
@@ -7475,7 +7475,7 @@
           <p:cNvPr id="2" name="">
             <a:extLst xmlns:a="http://schemas.openxmlformats.org/drawingml/2006/main">
               <a:ext uri="{FF2B5EF4-FFF2-40B4-BE49-F238E27FC236}">
-                <a16:creationId xmlns:a16="http://schemas.microsoft.com/office/drawing/2014/main" id="{C33CA065-CFE1-43B8-B0BB-EAAA3034C339}"/>
+                <a16:creationId xmlns:a16="http://schemas.microsoft.com/office/drawing/2014/main" id="{5872AB84-191B-451C-87B5-C4D723FE56CD}"/>
               </a:ext>
             </a:extLst>
           </p:cNvPr>
@@ -7485,7 +7485,7 @@
           <p:nvPr/>
         </p:nvPicPr>
         <p:blipFill>
-          <a:blip xmlns:r="http://schemas.openxmlformats.org/officeDocument/2006/relationships" xmlns:a="http://schemas.openxmlformats.org/drawingml/2006/main" r:embed="Re22173731dba44cb"/>
+          <a:blip xmlns:r="http://schemas.openxmlformats.org/officeDocument/2006/relationships" xmlns:a="http://schemas.openxmlformats.org/drawingml/2006/main" r:embed="Raaaf3cd056b04ac8"/>
           <a:stretch xmlns:a="http://schemas.openxmlformats.org/drawingml/2006/main"/>
         </p:blipFill>
         <p:spPr>
@@ -7501,7 +7501,7 @@
     </p:spTree>
     <p:extLst>
       <p:ext uri="{BB962C8B-B14F-4D97-AF65-F5344CB8AC3E}">
-        <p14:creationId xmlns:p14="http://schemas.microsoft.com/office/powerpoint/2010/main" val="1323209826"/>
+        <p14:creationId xmlns:p14="http://schemas.microsoft.com/office/powerpoint/2010/main" val="1060157809"/>
       </p:ext>
     </p:extLst>
   </p:cSld>
@@ -7525,7 +7525,7 @@
           <p:cNvPr id="2" name="">
             <a:extLst xmlns:a="http://schemas.openxmlformats.org/drawingml/2006/main">
               <a:ext uri="{FF2B5EF4-FFF2-40B4-BE49-F238E27FC236}">
-                <a16:creationId xmlns:a16="http://schemas.microsoft.com/office/drawing/2014/main" id="{F70F508B-C2B0-4F74-AB36-4F5A3F256614}"/>
+                <a16:creationId xmlns:a16="http://schemas.microsoft.com/office/drawing/2014/main" id="{1E7EAD01-1E1D-49E7-89F1-E4F2AD58AD4C}"/>
               </a:ext>
             </a:extLst>
           </p:cNvPr>
@@ -7535,7 +7535,7 @@
           <p:nvPr/>
         </p:nvPicPr>
         <p:blipFill>
-          <a:blip xmlns:r="http://schemas.openxmlformats.org/officeDocument/2006/relationships" xmlns:a="http://schemas.openxmlformats.org/drawingml/2006/main" r:embed="R90d3b86478ff443e"/>
+          <a:blip xmlns:r="http://schemas.openxmlformats.org/officeDocument/2006/relationships" xmlns:a="http://schemas.openxmlformats.org/drawingml/2006/main" r:embed="R8bb90bd1cda44c59"/>
           <a:stretch xmlns:a="http://schemas.openxmlformats.org/drawingml/2006/main"/>
         </p:blipFill>
         <p:spPr>
@@ -7551,7 +7551,7 @@
     </p:spTree>
     <p:extLst>
       <p:ext uri="{BB962C8B-B14F-4D97-AF65-F5344CB8AC3E}">
-        <p14:creationId xmlns:p14="http://schemas.microsoft.com/office/powerpoint/2010/main" val="981313792"/>
+        <p14:creationId xmlns:p14="http://schemas.microsoft.com/office/powerpoint/2010/main" val="312486736"/>
       </p:ext>
     </p:extLst>
   </p:cSld>
@@ -7575,7 +7575,7 @@
           <p:cNvPr id="2" name="">
             <a:extLst xmlns:a="http://schemas.openxmlformats.org/drawingml/2006/main">
               <a:ext uri="{FF2B5EF4-FFF2-40B4-BE49-F238E27FC236}">
-                <a16:creationId xmlns:a16="http://schemas.microsoft.com/office/drawing/2014/main" id="{EF333B66-4DAB-40B8-8FDB-CD427954E0DA}"/>
+                <a16:creationId xmlns:a16="http://schemas.microsoft.com/office/drawing/2014/main" id="{463675EE-E1CE-41A3-A503-87F42B92557D}"/>
               </a:ext>
             </a:extLst>
           </p:cNvPr>
@@ -7585,7 +7585,7 @@
           <p:nvPr/>
         </p:nvPicPr>
         <p:blipFill>
-          <a:blip xmlns:r="http://schemas.openxmlformats.org/officeDocument/2006/relationships" xmlns:a="http://schemas.openxmlformats.org/drawingml/2006/main" r:embed="R4d4b3d5a6de2451a"/>
+          <a:blip xmlns:r="http://schemas.openxmlformats.org/officeDocument/2006/relationships" xmlns:a="http://schemas.openxmlformats.org/drawingml/2006/main" r:embed="R62bb8ca65eac42ef"/>
           <a:stretch xmlns:a="http://schemas.openxmlformats.org/drawingml/2006/main"/>
         </p:blipFill>
         <p:spPr>
@@ -7601,7 +7601,7 @@
     </p:spTree>
     <p:extLst>
       <p:ext uri="{BB962C8B-B14F-4D97-AF65-F5344CB8AC3E}">
-        <p14:creationId xmlns:p14="http://schemas.microsoft.com/office/powerpoint/2010/main" val="965524633"/>
+        <p14:creationId xmlns:p14="http://schemas.microsoft.com/office/powerpoint/2010/main" val="1369822199"/>
       </p:ext>
     </p:extLst>
   </p:cSld>
@@ -7625,7 +7625,7 @@
           <p:cNvPr id="2" name="">
             <a:extLst xmlns:a="http://schemas.openxmlformats.org/drawingml/2006/main">
               <a:ext uri="{FF2B5EF4-FFF2-40B4-BE49-F238E27FC236}">
-                <a16:creationId xmlns:a16="http://schemas.microsoft.com/office/drawing/2014/main" id="{0A375572-7CCD-44A7-B592-314687806001}"/>
+                <a16:creationId xmlns:a16="http://schemas.microsoft.com/office/drawing/2014/main" id="{4149FDF6-4C13-4BA3-8E9D-2CEC8C662FCA}"/>
               </a:ext>
             </a:extLst>
           </p:cNvPr>
@@ -7635,7 +7635,7 @@
           <p:nvPr/>
         </p:nvPicPr>
         <p:blipFill>
-          <a:blip xmlns:r="http://schemas.openxmlformats.org/officeDocument/2006/relationships" xmlns:a="http://schemas.openxmlformats.org/drawingml/2006/main" r:embed="Re4497d1c2ea644c8"/>
+          <a:blip xmlns:r="http://schemas.openxmlformats.org/officeDocument/2006/relationships" xmlns:a="http://schemas.openxmlformats.org/drawingml/2006/main" r:embed="Rb53cef80d1ef4616"/>
           <a:stretch xmlns:a="http://schemas.openxmlformats.org/drawingml/2006/main"/>
         </p:blipFill>
         <p:spPr>
@@ -7651,7 +7651,7 @@
     </p:spTree>
     <p:extLst>
       <p:ext uri="{BB962C8B-B14F-4D97-AF65-F5344CB8AC3E}">
-        <p14:creationId xmlns:p14="http://schemas.microsoft.com/office/powerpoint/2010/main" val="929993227"/>
+        <p14:creationId xmlns:p14="http://schemas.microsoft.com/office/powerpoint/2010/main" val="1273190369"/>
       </p:ext>
     </p:extLst>
   </p:cSld>
@@ -7675,7 +7675,7 @@
           <p:cNvPr id="2" name="">
             <a:extLst xmlns:a="http://schemas.openxmlformats.org/drawingml/2006/main">
               <a:ext uri="{FF2B5EF4-FFF2-40B4-BE49-F238E27FC236}">
-                <a16:creationId xmlns:a16="http://schemas.microsoft.com/office/drawing/2014/main" id="{536F0B1A-3209-4E49-8AF2-E9FE10A1989E}"/>
+                <a16:creationId xmlns:a16="http://schemas.microsoft.com/office/drawing/2014/main" id="{7E53E84F-7FB9-48D9-93D3-DCB04D3E32F0}"/>
               </a:ext>
             </a:extLst>
           </p:cNvPr>
@@ -7685,7 +7685,7 @@
           <p:nvPr/>
         </p:nvPicPr>
         <p:blipFill>
-          <a:blip xmlns:r="http://schemas.openxmlformats.org/officeDocument/2006/relationships" xmlns:a="http://schemas.openxmlformats.org/drawingml/2006/main" r:embed="R4939dde0ecec4c6d"/>
+          <a:blip xmlns:r="http://schemas.openxmlformats.org/officeDocument/2006/relationships" xmlns:a="http://schemas.openxmlformats.org/drawingml/2006/main" r:embed="R713e3af2db6640dc"/>
           <a:stretch xmlns:a="http://schemas.openxmlformats.org/drawingml/2006/main"/>
         </p:blipFill>
         <p:spPr>
@@ -7701,7 +7701,7 @@
     </p:spTree>
     <p:extLst>
       <p:ext uri="{BB962C8B-B14F-4D97-AF65-F5344CB8AC3E}">
-        <p14:creationId xmlns:p14="http://schemas.microsoft.com/office/powerpoint/2010/main" val="1935373792"/>
+        <p14:creationId xmlns:p14="http://schemas.microsoft.com/office/powerpoint/2010/main" val="366447789"/>
       </p:ext>
     </p:extLst>
   </p:cSld>
@@ -7725,7 +7725,7 @@
           <p:cNvPr id="2" name="">
             <a:extLst xmlns:a="http://schemas.openxmlformats.org/drawingml/2006/main">
               <a:ext uri="{FF2B5EF4-FFF2-40B4-BE49-F238E27FC236}">
-                <a16:creationId xmlns:a16="http://schemas.microsoft.com/office/drawing/2014/main" id="{F3056C05-3ACA-44E8-BAF7-1E23DCEC500E}"/>
+                <a16:creationId xmlns:a16="http://schemas.microsoft.com/office/drawing/2014/main" id="{4364AF3E-CCA0-4923-848E-934DF8270567}"/>
               </a:ext>
             </a:extLst>
           </p:cNvPr>
@@ -7735,7 +7735,7 @@
           <p:nvPr/>
         </p:nvPicPr>
         <p:blipFill>
-          <a:blip xmlns:r="http://schemas.openxmlformats.org/officeDocument/2006/relationships" xmlns:a="http://schemas.openxmlformats.org/drawingml/2006/main" r:embed="R3d8fcde613dd4c9a"/>
+          <a:blip xmlns:r="http://schemas.openxmlformats.org/officeDocument/2006/relationships" xmlns:a="http://schemas.openxmlformats.org/drawingml/2006/main" r:embed="R2ef884fac95247c8"/>
           <a:stretch xmlns:a="http://schemas.openxmlformats.org/drawingml/2006/main"/>
         </p:blipFill>
         <p:spPr>
@@ -7751,7 +7751,7 @@
     </p:spTree>
     <p:extLst>
       <p:ext uri="{BB962C8B-B14F-4D97-AF65-F5344CB8AC3E}">
-        <p14:creationId xmlns:p14="http://schemas.microsoft.com/office/powerpoint/2010/main" val="35666833"/>
+        <p14:creationId xmlns:p14="http://schemas.microsoft.com/office/powerpoint/2010/main" val="1209021464"/>
       </p:ext>
     </p:extLst>
   </p:cSld>
@@ -7775,7 +7775,7 @@
           <p:cNvPr id="2" name="">
             <a:extLst xmlns:a="http://schemas.openxmlformats.org/drawingml/2006/main">
               <a:ext uri="{FF2B5EF4-FFF2-40B4-BE49-F238E27FC236}">
-                <a16:creationId xmlns:a16="http://schemas.microsoft.com/office/drawing/2014/main" id="{A6D9A042-DE40-4A84-86C1-129B4E5D8B29}"/>
+                <a16:creationId xmlns:a16="http://schemas.microsoft.com/office/drawing/2014/main" id="{7987DA39-D88F-4622-90D5-316E92AB760E}"/>
               </a:ext>
             </a:extLst>
           </p:cNvPr>
@@ -7785,7 +7785,7 @@
           <p:nvPr/>
         </p:nvPicPr>
         <p:blipFill>
-          <a:blip xmlns:r="http://schemas.openxmlformats.org/officeDocument/2006/relationships" xmlns:a="http://schemas.openxmlformats.org/drawingml/2006/main" r:embed="R24ccae8755a04430"/>
+          <a:blip xmlns:r="http://schemas.openxmlformats.org/officeDocument/2006/relationships" xmlns:a="http://schemas.openxmlformats.org/drawingml/2006/main" r:embed="Rfa25b2cc1f8642d2"/>
           <a:stretch xmlns:a="http://schemas.openxmlformats.org/drawingml/2006/main"/>
         </p:blipFill>
         <p:spPr>
@@ -7801,7 +7801,7 @@
     </p:spTree>
     <p:extLst>
       <p:ext uri="{BB962C8B-B14F-4D97-AF65-F5344CB8AC3E}">
-        <p14:creationId xmlns:p14="http://schemas.microsoft.com/office/powerpoint/2010/main" val="386954444"/>
+        <p14:creationId xmlns:p14="http://schemas.microsoft.com/office/powerpoint/2010/main" val="1521147150"/>
       </p:ext>
     </p:extLst>
   </p:cSld>
@@ -7825,7 +7825,7 @@
           <p:cNvPr id="2" name="">
             <a:extLst xmlns:a="http://schemas.openxmlformats.org/drawingml/2006/main">
               <a:ext uri="{FF2B5EF4-FFF2-40B4-BE49-F238E27FC236}">
-                <a16:creationId xmlns:a16="http://schemas.microsoft.com/office/drawing/2014/main" id="{01B0BCFB-46B4-4D86-A6CA-6399E18DA78C}"/>
+                <a16:creationId xmlns:a16="http://schemas.microsoft.com/office/drawing/2014/main" id="{7654C2A0-4E8B-42E9-AC57-ACF2A7E086C5}"/>
               </a:ext>
             </a:extLst>
           </p:cNvPr>
@@ -7835,7 +7835,7 @@
           <p:nvPr/>
         </p:nvPicPr>
         <p:blipFill>
-          <a:blip xmlns:r="http://schemas.openxmlformats.org/officeDocument/2006/relationships" xmlns:a="http://schemas.openxmlformats.org/drawingml/2006/main" r:embed="Rccb47b340bc54d86"/>
+          <a:blip xmlns:r="http://schemas.openxmlformats.org/officeDocument/2006/relationships" xmlns:a="http://schemas.openxmlformats.org/drawingml/2006/main" r:embed="R654900dbdb834677"/>
           <a:stretch xmlns:a="http://schemas.openxmlformats.org/drawingml/2006/main"/>
         </p:blipFill>
         <p:spPr>
@@ -7851,7 +7851,7 @@
     </p:spTree>
     <p:extLst>
       <p:ext uri="{BB962C8B-B14F-4D97-AF65-F5344CB8AC3E}">
-        <p14:creationId xmlns:p14="http://schemas.microsoft.com/office/powerpoint/2010/main" val="1815424753"/>
+        <p14:creationId xmlns:p14="http://schemas.microsoft.com/office/powerpoint/2010/main" val="1237094069"/>
       </p:ext>
     </p:extLst>
   </p:cSld>
@@ -7875,7 +7875,7 @@
           <p:cNvPr id="2" name="">
             <a:extLst xmlns:a="http://schemas.openxmlformats.org/drawingml/2006/main">
               <a:ext uri="{FF2B5EF4-FFF2-40B4-BE49-F238E27FC236}">
-                <a16:creationId xmlns:a16="http://schemas.microsoft.com/office/drawing/2014/main" id="{2346E97A-880D-4CF3-9A6B-1EA60940FEA1}"/>
+                <a16:creationId xmlns:a16="http://schemas.microsoft.com/office/drawing/2014/main" id="{8B961FAC-660D-4AF1-8364-B59476AE7433}"/>
               </a:ext>
             </a:extLst>
           </p:cNvPr>
@@ -7885,7 +7885,7 @@
           <p:nvPr/>
         </p:nvPicPr>
         <p:blipFill>
-          <a:blip xmlns:r="http://schemas.openxmlformats.org/officeDocument/2006/relationships" xmlns:a="http://schemas.openxmlformats.org/drawingml/2006/main" r:embed="Rc2331b6c5aa64013"/>
+          <a:blip xmlns:r="http://schemas.openxmlformats.org/officeDocument/2006/relationships" xmlns:a="http://schemas.openxmlformats.org/drawingml/2006/main" r:embed="R5997079b33a845f1"/>
           <a:stretch xmlns:a="http://schemas.openxmlformats.org/drawingml/2006/main"/>
         </p:blipFill>
         <p:spPr>
@@ -7901,7 +7901,7 @@
     </p:spTree>
     <p:extLst>
       <p:ext uri="{BB962C8B-B14F-4D97-AF65-F5344CB8AC3E}">
-        <p14:creationId xmlns:p14="http://schemas.microsoft.com/office/powerpoint/2010/main" val="976840321"/>
+        <p14:creationId xmlns:p14="http://schemas.microsoft.com/office/powerpoint/2010/main" val="183322163"/>
       </p:ext>
     </p:extLst>
   </p:cSld>
@@ -7925,7 +7925,7 @@
           <p:cNvPr id="2" name="">
             <a:extLst xmlns:a="http://schemas.openxmlformats.org/drawingml/2006/main">
               <a:ext uri="{FF2B5EF4-FFF2-40B4-BE49-F238E27FC236}">
-                <a16:creationId xmlns:a16="http://schemas.microsoft.com/office/drawing/2014/main" id="{87C15964-C622-4F6B-9F28-488D0D535359}"/>
+                <a16:creationId xmlns:a16="http://schemas.microsoft.com/office/drawing/2014/main" id="{0A0248DF-88A0-4602-B000-63F423CAF3C1}"/>
               </a:ext>
             </a:extLst>
           </p:cNvPr>
@@ -7935,7 +7935,7 @@
           <p:nvPr/>
         </p:nvPicPr>
         <p:blipFill>
-          <a:blip xmlns:r="http://schemas.openxmlformats.org/officeDocument/2006/relationships" xmlns:a="http://schemas.openxmlformats.org/drawingml/2006/main" r:embed="Ra2eb12a42c2f4d41"/>
+          <a:blip xmlns:r="http://schemas.openxmlformats.org/officeDocument/2006/relationships" xmlns:a="http://schemas.openxmlformats.org/drawingml/2006/main" r:embed="Re45032a5b48a49e6"/>
           <a:stretch xmlns:a="http://schemas.openxmlformats.org/drawingml/2006/main"/>
         </p:blipFill>
         <p:spPr>
@@ -7951,7 +7951,7 @@
     </p:spTree>
     <p:extLst>
       <p:ext uri="{BB962C8B-B14F-4D97-AF65-F5344CB8AC3E}">
-        <p14:creationId xmlns:p14="http://schemas.microsoft.com/office/powerpoint/2010/main" val="269007755"/>
+        <p14:creationId xmlns:p14="http://schemas.microsoft.com/office/powerpoint/2010/main" val="1036351740"/>
       </p:ext>
     </p:extLst>
   </p:cSld>
@@ -7975,7 +7975,7 @@
           <p:cNvPr id="2" name="">
             <a:extLst xmlns:a="http://schemas.openxmlformats.org/drawingml/2006/main">
               <a:ext uri="{FF2B5EF4-FFF2-40B4-BE49-F238E27FC236}">
-                <a16:creationId xmlns:a16="http://schemas.microsoft.com/office/drawing/2014/main" id="{3A1BF246-49E5-4378-87E0-BA459E55CD7A}"/>
+                <a16:creationId xmlns:a16="http://schemas.microsoft.com/office/drawing/2014/main" id="{E2F637B2-6138-44F8-87D6-8CFE78E9CA34}"/>
               </a:ext>
             </a:extLst>
           </p:cNvPr>
@@ -7985,7 +7985,7 @@
           <p:nvPr/>
         </p:nvPicPr>
         <p:blipFill>
-          <a:blip xmlns:r="http://schemas.openxmlformats.org/officeDocument/2006/relationships" xmlns:a="http://schemas.openxmlformats.org/drawingml/2006/main" r:embed="Rfe7878a341354657"/>
+          <a:blip xmlns:r="http://schemas.openxmlformats.org/officeDocument/2006/relationships" xmlns:a="http://schemas.openxmlformats.org/drawingml/2006/main" r:embed="R08d9801629524676"/>
           <a:stretch xmlns:a="http://schemas.openxmlformats.org/drawingml/2006/main"/>
         </p:blipFill>
         <p:spPr>
@@ -8001,7 +8001,7 @@
     </p:spTree>
     <p:extLst>
       <p:ext uri="{BB962C8B-B14F-4D97-AF65-F5344CB8AC3E}">
-        <p14:creationId xmlns:p14="http://schemas.microsoft.com/office/powerpoint/2010/main" val="562520599"/>
+        <p14:creationId xmlns:p14="http://schemas.microsoft.com/office/powerpoint/2010/main" val="1170608869"/>
       </p:ext>
     </p:extLst>
   </p:cSld>
@@ -8025,7 +8025,7 @@
           <p:cNvPr id="2" name="">
             <a:extLst xmlns:a="http://schemas.openxmlformats.org/drawingml/2006/main">
               <a:ext uri="{FF2B5EF4-FFF2-40B4-BE49-F238E27FC236}">
-                <a16:creationId xmlns:a16="http://schemas.microsoft.com/office/drawing/2014/main" id="{1C4B7379-39A3-4275-BD4A-FA55CE572761}"/>
+                <a16:creationId xmlns:a16="http://schemas.microsoft.com/office/drawing/2014/main" id="{07BCE2E8-1173-44CC-8965-BD10338E07BA}"/>
               </a:ext>
             </a:extLst>
           </p:cNvPr>
@@ -8035,7 +8035,7 @@
           <p:nvPr/>
         </p:nvPicPr>
         <p:blipFill>
-          <a:blip xmlns:r="http://schemas.openxmlformats.org/officeDocument/2006/relationships" xmlns:a="http://schemas.openxmlformats.org/drawingml/2006/main" r:embed="R75ab0ccf604741ee"/>
+          <a:blip xmlns:r="http://schemas.openxmlformats.org/officeDocument/2006/relationships" xmlns:a="http://schemas.openxmlformats.org/drawingml/2006/main" r:embed="R611d3ffd87f44b67"/>
           <a:stretch xmlns:a="http://schemas.openxmlformats.org/drawingml/2006/main"/>
         </p:blipFill>
         <p:spPr>
@@ -8051,7 +8051,7 @@
     </p:spTree>
     <p:extLst>
       <p:ext uri="{BB962C8B-B14F-4D97-AF65-F5344CB8AC3E}">
-        <p14:creationId xmlns:p14="http://schemas.microsoft.com/office/powerpoint/2010/main" val="1587940061"/>
+        <p14:creationId xmlns:p14="http://schemas.microsoft.com/office/powerpoint/2010/main" val="1724821564"/>
       </p:ext>
     </p:extLst>
   </p:cSld>
@@ -8075,7 +8075,7 @@
           <p:cNvPr id="2" name="">
             <a:extLst xmlns:a="http://schemas.openxmlformats.org/drawingml/2006/main">
               <a:ext uri="{FF2B5EF4-FFF2-40B4-BE49-F238E27FC236}">
-                <a16:creationId xmlns:a16="http://schemas.microsoft.com/office/drawing/2014/main" id="{7C02171A-96AB-4DE4-B40A-B9DAF602CCD4}"/>
+                <a16:creationId xmlns:a16="http://schemas.microsoft.com/office/drawing/2014/main" id="{4C75FACE-204A-4D2A-97C7-FD5409389F57}"/>
               </a:ext>
             </a:extLst>
           </p:cNvPr>
@@ -8085,7 +8085,7 @@
           <p:nvPr/>
         </p:nvPicPr>
         <p:blipFill>
-          <a:blip xmlns:r="http://schemas.openxmlformats.org/officeDocument/2006/relationships" xmlns:a="http://schemas.openxmlformats.org/drawingml/2006/main" r:embed="R72c8815a37114df9"/>
+          <a:blip xmlns:r="http://schemas.openxmlformats.org/officeDocument/2006/relationships" xmlns:a="http://schemas.openxmlformats.org/drawingml/2006/main" r:embed="R5032e245fbf74040"/>
           <a:stretch xmlns:a="http://schemas.openxmlformats.org/drawingml/2006/main"/>
         </p:blipFill>
         <p:spPr>
@@ -8101,7 +8101,7 @@
     </p:spTree>
     <p:extLst>
       <p:ext uri="{BB962C8B-B14F-4D97-AF65-F5344CB8AC3E}">
-        <p14:creationId xmlns:p14="http://schemas.microsoft.com/office/powerpoint/2010/main" val="1975559188"/>
+        <p14:creationId xmlns:p14="http://schemas.microsoft.com/office/powerpoint/2010/main" val="1968711083"/>
       </p:ext>
     </p:extLst>
   </p:cSld>
@@ -8125,7 +8125,7 @@
           <p:cNvPr id="2" name="">
             <a:extLst xmlns:a="http://schemas.openxmlformats.org/drawingml/2006/main">
               <a:ext uri="{FF2B5EF4-FFF2-40B4-BE49-F238E27FC236}">
-                <a16:creationId xmlns:a16="http://schemas.microsoft.com/office/drawing/2014/main" id="{63074B55-808C-46B0-A3A5-8A6B3A30DA35}"/>
+                <a16:creationId xmlns:a16="http://schemas.microsoft.com/office/drawing/2014/main" id="{81613FB6-4D9F-41D4-BB0F-85C2CA2F5B36}"/>
               </a:ext>
             </a:extLst>
           </p:cNvPr>
@@ -8135,7 +8135,7 @@
           <p:nvPr/>
         </p:nvPicPr>
         <p:blipFill>
-          <a:blip xmlns:r="http://schemas.openxmlformats.org/officeDocument/2006/relationships" xmlns:a="http://schemas.openxmlformats.org/drawingml/2006/main" r:embed="R63aa375ec0a64367"/>
+          <a:blip xmlns:r="http://schemas.openxmlformats.org/officeDocument/2006/relationships" xmlns:a="http://schemas.openxmlformats.org/drawingml/2006/main" r:embed="R7f393480af0044a8"/>
           <a:stretch xmlns:a="http://schemas.openxmlformats.org/drawingml/2006/main"/>
         </p:blipFill>
         <p:spPr>
@@ -8151,7 +8151,7 @@
     </p:spTree>
     <p:extLst>
       <p:ext uri="{BB962C8B-B14F-4D97-AF65-F5344CB8AC3E}">
-        <p14:creationId xmlns:p14="http://schemas.microsoft.com/office/powerpoint/2010/main" val="134065753"/>
+        <p14:creationId xmlns:p14="http://schemas.microsoft.com/office/powerpoint/2010/main" val="1623775717"/>
       </p:ext>
     </p:extLst>
   </p:cSld>
@@ -8175,7 +8175,7 @@
           <p:cNvPr id="2" name="">
             <a:extLst xmlns:a="http://schemas.openxmlformats.org/drawingml/2006/main">
               <a:ext uri="{FF2B5EF4-FFF2-40B4-BE49-F238E27FC236}">
-                <a16:creationId xmlns:a16="http://schemas.microsoft.com/office/drawing/2014/main" id="{5747E944-FE6A-43FC-A69A-8B8CAED9CFA0}"/>
+                <a16:creationId xmlns:a16="http://schemas.microsoft.com/office/drawing/2014/main" id="{489890AB-EE03-4513-9EAC-71D7C4FCBD34}"/>
               </a:ext>
             </a:extLst>
           </p:cNvPr>
@@ -8185,7 +8185,7 @@
           <p:nvPr/>
         </p:nvPicPr>
         <p:blipFill>
-          <a:blip xmlns:r="http://schemas.openxmlformats.org/officeDocument/2006/relationships" xmlns:a="http://schemas.openxmlformats.org/drawingml/2006/main" r:embed="R1c2d083e170b48e3"/>
+          <a:blip xmlns:r="http://schemas.openxmlformats.org/officeDocument/2006/relationships" xmlns:a="http://schemas.openxmlformats.org/drawingml/2006/main" r:embed="R748908ff670f4207"/>
           <a:stretch xmlns:a="http://schemas.openxmlformats.org/drawingml/2006/main"/>
         </p:blipFill>
         <p:spPr>
@@ -8201,7 +8201,7 @@
     </p:spTree>
     <p:extLst>
       <p:ext uri="{BB962C8B-B14F-4D97-AF65-F5344CB8AC3E}">
-        <p14:creationId xmlns:p14="http://schemas.microsoft.com/office/powerpoint/2010/main" val="1866776707"/>
+        <p14:creationId xmlns:p14="http://schemas.microsoft.com/office/powerpoint/2010/main" val="1875145162"/>
       </p:ext>
     </p:extLst>
   </p:cSld>
@@ -8225,7 +8225,7 @@
           <p:cNvPr id="2" name="">
             <a:extLst xmlns:a="http://schemas.openxmlformats.org/drawingml/2006/main">
               <a:ext uri="{FF2B5EF4-FFF2-40B4-BE49-F238E27FC236}">
-                <a16:creationId xmlns:a16="http://schemas.microsoft.com/office/drawing/2014/main" id="{6261833B-9A89-4F22-A4B1-B071CE7360C8}"/>
+                <a16:creationId xmlns:a16="http://schemas.microsoft.com/office/drawing/2014/main" id="{2710D82D-C1B6-4390-B6D5-13808A455314}"/>
               </a:ext>
             </a:extLst>
           </p:cNvPr>
@@ -8235,7 +8235,7 @@
           <p:nvPr/>
         </p:nvPicPr>
         <p:blipFill>
-          <a:blip xmlns:r="http://schemas.openxmlformats.org/officeDocument/2006/relationships" xmlns:a="http://schemas.openxmlformats.org/drawingml/2006/main" r:embed="Rd5913f1e96f94c5b"/>
+          <a:blip xmlns:r="http://schemas.openxmlformats.org/officeDocument/2006/relationships" xmlns:a="http://schemas.openxmlformats.org/drawingml/2006/main" r:embed="R6aa61716fed04a55"/>
           <a:stretch xmlns:a="http://schemas.openxmlformats.org/drawingml/2006/main"/>
         </p:blipFill>
         <p:spPr>
@@ -8251,7 +8251,7 @@
     </p:spTree>
     <p:extLst>
       <p:ext uri="{BB962C8B-B14F-4D97-AF65-F5344CB8AC3E}">
-        <p14:creationId xmlns:p14="http://schemas.microsoft.com/office/powerpoint/2010/main" val="2143056922"/>
+        <p14:creationId xmlns:p14="http://schemas.microsoft.com/office/powerpoint/2010/main" val="1617526803"/>
       </p:ext>
     </p:extLst>
   </p:cSld>
@@ -8275,7 +8275,7 @@
           <p:cNvPr id="2" name="">
             <a:extLst xmlns:a="http://schemas.openxmlformats.org/drawingml/2006/main">
               <a:ext uri="{FF2B5EF4-FFF2-40B4-BE49-F238E27FC236}">
-                <a16:creationId xmlns:a16="http://schemas.microsoft.com/office/drawing/2014/main" id="{521144E1-F363-4DA2-B8B6-C353395CF9CC}"/>
+                <a16:creationId xmlns:a16="http://schemas.microsoft.com/office/drawing/2014/main" id="{0BDAB818-4B14-44A1-A6EF-CF1ECB47A313}"/>
               </a:ext>
             </a:extLst>
           </p:cNvPr>
@@ -8285,7 +8285,7 @@
           <p:nvPr/>
         </p:nvPicPr>
         <p:blipFill>
-          <a:blip xmlns:r="http://schemas.openxmlformats.org/officeDocument/2006/relationships" xmlns:a="http://schemas.openxmlformats.org/drawingml/2006/main" r:embed="R8efc1f0cdfd2407c"/>
+          <a:blip xmlns:r="http://schemas.openxmlformats.org/officeDocument/2006/relationships" xmlns:a="http://schemas.openxmlformats.org/drawingml/2006/main" r:embed="R552c870f257b45a6"/>
           <a:stretch xmlns:a="http://schemas.openxmlformats.org/drawingml/2006/main"/>
         </p:blipFill>
         <p:spPr>
@@ -8301,7 +8301,7 @@
     </p:spTree>
     <p:extLst>
       <p:ext uri="{BB962C8B-B14F-4D97-AF65-F5344CB8AC3E}">
-        <p14:creationId xmlns:p14="http://schemas.microsoft.com/office/powerpoint/2010/main" val="410535360"/>
+        <p14:creationId xmlns:p14="http://schemas.microsoft.com/office/powerpoint/2010/main" val="882854979"/>
       </p:ext>
     </p:extLst>
   </p:cSld>
@@ -8325,7 +8325,7 @@
           <p:cNvPr id="2" name="">
             <a:extLst xmlns:a="http://schemas.openxmlformats.org/drawingml/2006/main">
               <a:ext uri="{FF2B5EF4-FFF2-40B4-BE49-F238E27FC236}">
-                <a16:creationId xmlns:a16="http://schemas.microsoft.com/office/drawing/2014/main" id="{26ABBA3C-62D7-4159-8597-0A47DA1A3DB8}"/>
+                <a16:creationId xmlns:a16="http://schemas.microsoft.com/office/drawing/2014/main" id="{8ACCB798-F507-408D-B75A-6BB0435BF75B}"/>
               </a:ext>
             </a:extLst>
           </p:cNvPr>
@@ -8335,7 +8335,7 @@
           <p:nvPr/>
         </p:nvPicPr>
         <p:blipFill>
-          <a:blip xmlns:r="http://schemas.openxmlformats.org/officeDocument/2006/relationships" xmlns:a="http://schemas.openxmlformats.org/drawingml/2006/main" r:embed="R393f398d157848d9"/>
+          <a:blip xmlns:r="http://schemas.openxmlformats.org/officeDocument/2006/relationships" xmlns:a="http://schemas.openxmlformats.org/drawingml/2006/main" r:embed="Rd1c3a6dd86554e98"/>
           <a:stretch xmlns:a="http://schemas.openxmlformats.org/drawingml/2006/main"/>
         </p:blipFill>
         <p:spPr>
@@ -8351,7 +8351,7 @@
     </p:spTree>
     <p:extLst>
       <p:ext uri="{BB962C8B-B14F-4D97-AF65-F5344CB8AC3E}">
-        <p14:creationId xmlns:p14="http://schemas.microsoft.com/office/powerpoint/2010/main" val="860455336"/>
+        <p14:creationId xmlns:p14="http://schemas.microsoft.com/office/powerpoint/2010/main" val="287325579"/>
       </p:ext>
     </p:extLst>
   </p:cSld>
@@ -8375,7 +8375,7 @@
           <p:cNvPr id="2" name="">
             <a:extLst xmlns:a="http://schemas.openxmlformats.org/drawingml/2006/main">
               <a:ext uri="{FF2B5EF4-FFF2-40B4-BE49-F238E27FC236}">
-                <a16:creationId xmlns:a16="http://schemas.microsoft.com/office/drawing/2014/main" id="{ABC715D0-3BB3-45D6-89C8-D7EF44804E9A}"/>
+                <a16:creationId xmlns:a16="http://schemas.microsoft.com/office/drawing/2014/main" id="{D2DCE41B-F25D-4106-9D15-EB718D98F2D8}"/>
               </a:ext>
             </a:extLst>
           </p:cNvPr>
@@ -8385,7 +8385,7 @@
           <p:nvPr/>
         </p:nvPicPr>
         <p:blipFill>
-          <a:blip xmlns:r="http://schemas.openxmlformats.org/officeDocument/2006/relationships" xmlns:a="http://schemas.openxmlformats.org/drawingml/2006/main" r:embed="Rc642574b0ecc46f8"/>
+          <a:blip xmlns:r="http://schemas.openxmlformats.org/officeDocument/2006/relationships" xmlns:a="http://schemas.openxmlformats.org/drawingml/2006/main" r:embed="R0fd1f818b03e482a"/>
           <a:stretch xmlns:a="http://schemas.openxmlformats.org/drawingml/2006/main"/>
         </p:blipFill>
         <p:spPr>
@@ -8401,7 +8401,7 @@
     </p:spTree>
     <p:extLst>
       <p:ext uri="{BB962C8B-B14F-4D97-AF65-F5344CB8AC3E}">
-        <p14:creationId xmlns:p14="http://schemas.microsoft.com/office/powerpoint/2010/main" val="769316843"/>
+        <p14:creationId xmlns:p14="http://schemas.microsoft.com/office/powerpoint/2010/main" val="2093085360"/>
       </p:ext>
     </p:extLst>
   </p:cSld>
@@ -8425,7 +8425,7 @@
           <p:cNvPr id="2" name="">
             <a:extLst xmlns:a="http://schemas.openxmlformats.org/drawingml/2006/main">
               <a:ext uri="{FF2B5EF4-FFF2-40B4-BE49-F238E27FC236}">
-                <a16:creationId xmlns:a16="http://schemas.microsoft.com/office/drawing/2014/main" id="{25960B0B-FCC4-42FC-9158-34E97041FDE6}"/>
+                <a16:creationId xmlns:a16="http://schemas.microsoft.com/office/drawing/2014/main" id="{CDF22B10-2449-446F-8553-EFCA8896372F}"/>
               </a:ext>
             </a:extLst>
           </p:cNvPr>
@@ -8435,7 +8435,7 @@
           <p:nvPr/>
         </p:nvPicPr>
         <p:blipFill>
-          <a:blip xmlns:r="http://schemas.openxmlformats.org/officeDocument/2006/relationships" xmlns:a="http://schemas.openxmlformats.org/drawingml/2006/main" r:embed="R833ad94768674a58"/>
+          <a:blip xmlns:r="http://schemas.openxmlformats.org/officeDocument/2006/relationships" xmlns:a="http://schemas.openxmlformats.org/drawingml/2006/main" r:embed="R5b58cf0f9f1a464e"/>
           <a:stretch xmlns:a="http://schemas.openxmlformats.org/drawingml/2006/main"/>
         </p:blipFill>
         <p:spPr>
@@ -8451,7 +8451,7 @@
     </p:spTree>
     <p:extLst>
       <p:ext uri="{BB962C8B-B14F-4D97-AF65-F5344CB8AC3E}">
-        <p14:creationId xmlns:p14="http://schemas.microsoft.com/office/powerpoint/2010/main" val="2087080316"/>
+        <p14:creationId xmlns:p14="http://schemas.microsoft.com/office/powerpoint/2010/main" val="1777885429"/>
       </p:ext>
     </p:extLst>
   </p:cSld>
@@ -8475,7 +8475,7 @@
           <p:cNvPr id="2" name="">
             <a:extLst xmlns:a="http://schemas.openxmlformats.org/drawingml/2006/main">
               <a:ext uri="{FF2B5EF4-FFF2-40B4-BE49-F238E27FC236}">
-                <a16:creationId xmlns:a16="http://schemas.microsoft.com/office/drawing/2014/main" id="{975FAE32-5068-4585-8430-A8392BC75B77}"/>
+                <a16:creationId xmlns:a16="http://schemas.microsoft.com/office/drawing/2014/main" id="{3B47E9B2-E6A5-4193-8743-5CAE121C3DE0}"/>
               </a:ext>
             </a:extLst>
           </p:cNvPr>
@@ -8485,7 +8485,7 @@
           <p:nvPr/>
         </p:nvPicPr>
         <p:blipFill>
-          <a:blip xmlns:r="http://schemas.openxmlformats.org/officeDocument/2006/relationships" xmlns:a="http://schemas.openxmlformats.org/drawingml/2006/main" r:embed="R78145e7dc3ae4340"/>
+          <a:blip xmlns:r="http://schemas.openxmlformats.org/officeDocument/2006/relationships" xmlns:a="http://schemas.openxmlformats.org/drawingml/2006/main" r:embed="Rf5a044256a5a4edc"/>
           <a:stretch xmlns:a="http://schemas.openxmlformats.org/drawingml/2006/main"/>
         </p:blipFill>
         <p:spPr>
@@ -8501,7 +8501,7 @@
     </p:spTree>
     <p:extLst>
       <p:ext uri="{BB962C8B-B14F-4D97-AF65-F5344CB8AC3E}">
-        <p14:creationId xmlns:p14="http://schemas.microsoft.com/office/powerpoint/2010/main" val="410501011"/>
+        <p14:creationId xmlns:p14="http://schemas.microsoft.com/office/powerpoint/2010/main" val="1789208830"/>
       </p:ext>
     </p:extLst>
   </p:cSld>
@@ -8525,7 +8525,7 @@
           <p:cNvPr id="2" name="">
             <a:extLst xmlns:a="http://schemas.openxmlformats.org/drawingml/2006/main">
               <a:ext uri="{FF2B5EF4-FFF2-40B4-BE49-F238E27FC236}">
-                <a16:creationId xmlns:a16="http://schemas.microsoft.com/office/drawing/2014/main" id="{59281466-56CF-4DA9-8FB8-B7AB210BD91D}"/>
+                <a16:creationId xmlns:a16="http://schemas.microsoft.com/office/drawing/2014/main" id="{46C69E3E-3775-427D-9D15-D3E7D90B83DB}"/>
               </a:ext>
             </a:extLst>
           </p:cNvPr>
@@ -8535,7 +8535,7 @@
           <p:nvPr/>
         </p:nvPicPr>
         <p:blipFill>
-          <a:blip xmlns:r="http://schemas.openxmlformats.org/officeDocument/2006/relationships" xmlns:a="http://schemas.openxmlformats.org/drawingml/2006/main" r:embed="R1a9188079e5c4232"/>
+          <a:blip xmlns:r="http://schemas.openxmlformats.org/officeDocument/2006/relationships" xmlns:a="http://schemas.openxmlformats.org/drawingml/2006/main" r:embed="Rec890f61a9424fb3"/>
           <a:stretch xmlns:a="http://schemas.openxmlformats.org/drawingml/2006/main"/>
         </p:blipFill>
         <p:spPr>
@@ -8551,7 +8551,7 @@
     </p:spTree>
     <p:extLst>
       <p:ext uri="{BB962C8B-B14F-4D97-AF65-F5344CB8AC3E}">
-        <p14:creationId xmlns:p14="http://schemas.microsoft.com/office/powerpoint/2010/main" val="918201764"/>
+        <p14:creationId xmlns:p14="http://schemas.microsoft.com/office/powerpoint/2010/main" val="499054909"/>
       </p:ext>
     </p:extLst>
   </p:cSld>
@@ -8575,7 +8575,7 @@
           <p:cNvPr id="2" name="">
             <a:extLst xmlns:a="http://schemas.openxmlformats.org/drawingml/2006/main">
               <a:ext uri="{FF2B5EF4-FFF2-40B4-BE49-F238E27FC236}">
-                <a16:creationId xmlns:a16="http://schemas.microsoft.com/office/drawing/2014/main" id="{14AD0975-0482-4EDF-9085-6004CED7C4CE}"/>
+                <a16:creationId xmlns:a16="http://schemas.microsoft.com/office/drawing/2014/main" id="{9874D772-830D-4C53-B5F9-F80C4B41A4CA}"/>
               </a:ext>
             </a:extLst>
           </p:cNvPr>
@@ -8585,7 +8585,7 @@
           <p:nvPr/>
         </p:nvPicPr>
         <p:blipFill>
-          <a:blip xmlns:r="http://schemas.openxmlformats.org/officeDocument/2006/relationships" xmlns:a="http://schemas.openxmlformats.org/drawingml/2006/main" r:embed="R7160b6b86b4e4af5"/>
+          <a:blip xmlns:r="http://schemas.openxmlformats.org/officeDocument/2006/relationships" xmlns:a="http://schemas.openxmlformats.org/drawingml/2006/main" r:embed="R178c22c9355e483c"/>
           <a:stretch xmlns:a="http://schemas.openxmlformats.org/drawingml/2006/main"/>
         </p:blipFill>
         <p:spPr>
@@ -8601,7 +8601,7 @@
     </p:spTree>
     <p:extLst>
       <p:ext uri="{BB962C8B-B14F-4D97-AF65-F5344CB8AC3E}">
-        <p14:creationId xmlns:p14="http://schemas.microsoft.com/office/powerpoint/2010/main" val="670270994"/>
+        <p14:creationId xmlns:p14="http://schemas.microsoft.com/office/powerpoint/2010/main" val="322709448"/>
       </p:ext>
     </p:extLst>
   </p:cSld>
@@ -8625,7 +8625,7 @@
           <p:cNvPr id="2" name="">
             <a:extLst xmlns:a="http://schemas.openxmlformats.org/drawingml/2006/main">
               <a:ext uri="{FF2B5EF4-FFF2-40B4-BE49-F238E27FC236}">
-                <a16:creationId xmlns:a16="http://schemas.microsoft.com/office/drawing/2014/main" id="{F78AA631-EC8E-42F7-B840-02E03597A28D}"/>
+                <a16:creationId xmlns:a16="http://schemas.microsoft.com/office/drawing/2014/main" id="{B21B198E-4031-401F-8107-709767B74E67}"/>
               </a:ext>
             </a:extLst>
           </p:cNvPr>
@@ -8635,7 +8635,7 @@
           <p:nvPr/>
         </p:nvPicPr>
         <p:blipFill>
-          <a:blip xmlns:r="http://schemas.openxmlformats.org/officeDocument/2006/relationships" xmlns:a="http://schemas.openxmlformats.org/drawingml/2006/main" r:embed="R1a1cba7485a44bda"/>
+          <a:blip xmlns:r="http://schemas.openxmlformats.org/officeDocument/2006/relationships" xmlns:a="http://schemas.openxmlformats.org/drawingml/2006/main" r:embed="Rffeff1b3c2d4446c"/>
           <a:stretch xmlns:a="http://schemas.openxmlformats.org/drawingml/2006/main"/>
         </p:blipFill>
         <p:spPr>
@@ -8651,7 +8651,7 @@
     </p:spTree>
     <p:extLst>
       <p:ext uri="{BB962C8B-B14F-4D97-AF65-F5344CB8AC3E}">
-        <p14:creationId xmlns:p14="http://schemas.microsoft.com/office/powerpoint/2010/main" val="808816450"/>
+        <p14:creationId xmlns:p14="http://schemas.microsoft.com/office/powerpoint/2010/main" val="786918464"/>
       </p:ext>
     </p:extLst>
   </p:cSld>

</xml_diff>